<commit_message>
Put the micro-lens array on the substrate underside
Both devices emit through the bottom, so the substrate's underside is the
outcoupling surface and it should show the array.  From this angle the
bottom face is never visible, so the array is drawn where it can be seen:
the two visible bottom edges are scalloped into touching semicircles,
which is what a micro-lens array looks like in section.

The pitch is adjusted to divide each edge exactly, so the array ends on a
whole lens at both corners rather than a clipped one -- the two edges have
different lengths (BW and BD), so a single fixed pitch cannot do that.

Emission arrows now start a lens-radius lower, otherwise their tails sit
inside the lenses.

Co-Authored-By: Claude Opus 5 <noreply@anthropic.com>
Claude-Session: https://claude.ai/code/session_014A61zHZtLZU5uPXAWC8gtS
</commit_message>
<xml_diff>
--- a/figures/device_stacks.pptx
+++ b/figures/device_stacks.pptx
@@ -3097,7 +3097,7 @@
         <p:spPr>
           <a:xfrm>
             <a:off x="2304579" y="4665587"/>
-            <a:ext cx="980386" cy="966627"/>
+            <a:ext cx="980386" cy="1015911"/>
           </a:xfrm>
           <a:custGeom>
             <a:avLst/>
@@ -3106,18 +3106,222 @@
             <a:cxnLst/>
             <a:rect l="l" t="t" r="r" b="b"/>
             <a:pathLst>
-              <a:path w="980386" h="966627">
+              <a:path w="980386" h="1015911">
                 <a:moveTo>
+                  <a:pt x="980386" y="0"/>
+                </a:moveTo>
+                <a:lnTo>
+                  <a:pt x="0" y="566043"/>
+                </a:lnTo>
+                <a:lnTo>
+                  <a:pt x="0" y="966627"/>
+                </a:lnTo>
+                <a:lnTo>
+                  <a:pt x="15561" y="1008468"/>
+                </a:lnTo>
+                <a:lnTo>
+                  <a:pt x="31123" y="1015894"/>
+                </a:lnTo>
+                <a:lnTo>
+                  <a:pt x="46685" y="1015911"/>
+                </a:lnTo>
+                <a:lnTo>
+                  <a:pt x="62246" y="1011050"/>
+                </a:lnTo>
+                <a:lnTo>
+                  <a:pt x="77808" y="1002066"/>
+                </a:lnTo>
+                <a:lnTo>
+                  <a:pt x="93370" y="988957"/>
+                </a:lnTo>
+                <a:lnTo>
+                  <a:pt x="108932" y="970970"/>
+                </a:lnTo>
+                <a:lnTo>
+                  <a:pt x="124493" y="945574"/>
+                </a:lnTo>
+                <a:lnTo>
+                  <a:pt x="140055" y="885764"/>
+                </a:lnTo>
+                <a:lnTo>
+                  <a:pt x="140055" y="885764"/>
+                </a:lnTo>
+                <a:lnTo>
+                  <a:pt x="155617" y="927605"/>
+                </a:lnTo>
+                <a:lnTo>
+                  <a:pt x="171178" y="935030"/>
+                </a:lnTo>
+                <a:lnTo>
+                  <a:pt x="186740" y="935048"/>
+                </a:lnTo>
+                <a:lnTo>
+                  <a:pt x="202302" y="930187"/>
+                </a:lnTo>
+                <a:lnTo>
+                  <a:pt x="217863" y="921202"/>
+                </a:lnTo>
+                <a:lnTo>
+                  <a:pt x="233425" y="908094"/>
+                </a:lnTo>
+                <a:lnTo>
+                  <a:pt x="248987" y="890106"/>
+                </a:lnTo>
+                <a:lnTo>
+                  <a:pt x="264548" y="864711"/>
+                </a:lnTo>
+                <a:lnTo>
+                  <a:pt x="280110" y="804901"/>
+                </a:lnTo>
+                <a:lnTo>
+                  <a:pt x="280110" y="804901"/>
+                </a:lnTo>
+                <a:lnTo>
+                  <a:pt x="295672" y="846741"/>
+                </a:lnTo>
+                <a:lnTo>
+                  <a:pt x="311233" y="854167"/>
+                </a:lnTo>
+                <a:lnTo>
+                  <a:pt x="326795" y="854185"/>
+                </a:lnTo>
+                <a:lnTo>
+                  <a:pt x="342357" y="849324"/>
+                </a:lnTo>
+                <a:lnTo>
+                  <a:pt x="357919" y="840339"/>
+                </a:lnTo>
+                <a:lnTo>
+                  <a:pt x="373480" y="827230"/>
+                </a:lnTo>
+                <a:lnTo>
+                  <a:pt x="389042" y="809243"/>
+                </a:lnTo>
+                <a:lnTo>
+                  <a:pt x="404604" y="783848"/>
+                </a:lnTo>
+                <a:lnTo>
+                  <a:pt x="420165" y="724037"/>
+                </a:lnTo>
+                <a:lnTo>
+                  <a:pt x="420165" y="724037"/>
+                </a:lnTo>
+                <a:lnTo>
+                  <a:pt x="435727" y="765878"/>
+                </a:lnTo>
+                <a:lnTo>
+                  <a:pt x="451289" y="773304"/>
+                </a:lnTo>
+                <a:lnTo>
+                  <a:pt x="466850" y="773321"/>
+                </a:lnTo>
+                <a:lnTo>
+                  <a:pt x="482412" y="768461"/>
+                </a:lnTo>
+                <a:lnTo>
+                  <a:pt x="497974" y="759476"/>
+                </a:lnTo>
+                <a:lnTo>
+                  <a:pt x="513535" y="746367"/>
+                </a:lnTo>
+                <a:lnTo>
+                  <a:pt x="529097" y="728380"/>
+                </a:lnTo>
+                <a:lnTo>
+                  <a:pt x="544659" y="702985"/>
+                </a:lnTo>
+                <a:lnTo>
+                  <a:pt x="560221" y="643174"/>
+                </a:lnTo>
+                <a:lnTo>
+                  <a:pt x="560221" y="643174"/>
+                </a:lnTo>
+                <a:lnTo>
+                  <a:pt x="575782" y="685015"/>
+                </a:lnTo>
+                <a:lnTo>
+                  <a:pt x="591344" y="692441"/>
+                </a:lnTo>
+                <a:lnTo>
+                  <a:pt x="606906" y="692458"/>
+                </a:lnTo>
+                <a:lnTo>
+                  <a:pt x="622467" y="687597"/>
+                </a:lnTo>
+                <a:lnTo>
+                  <a:pt x="638029" y="678613"/>
+                </a:lnTo>
+                <a:lnTo>
+                  <a:pt x="653591" y="665504"/>
+                </a:lnTo>
+                <a:lnTo>
+                  <a:pt x="669152" y="647516"/>
+                </a:lnTo>
+                <a:lnTo>
+                  <a:pt x="684714" y="622121"/>
+                </a:lnTo>
+                <a:lnTo>
+                  <a:pt x="700276" y="562311"/>
+                </a:lnTo>
+                <a:lnTo>
+                  <a:pt x="700276" y="562311"/>
+                </a:lnTo>
+                <a:lnTo>
+                  <a:pt x="715837" y="604152"/>
+                </a:lnTo>
+                <a:lnTo>
+                  <a:pt x="731399" y="611577"/>
+                </a:lnTo>
+                <a:lnTo>
+                  <a:pt x="746961" y="611595"/>
+                </a:lnTo>
+                <a:lnTo>
+                  <a:pt x="762522" y="606734"/>
+                </a:lnTo>
+                <a:lnTo>
+                  <a:pt x="778084" y="597749"/>
+                </a:lnTo>
+                <a:lnTo>
+                  <a:pt x="793646" y="584640"/>
+                </a:lnTo>
+                <a:lnTo>
+                  <a:pt x="809208" y="566653"/>
+                </a:lnTo>
+                <a:lnTo>
+                  <a:pt x="824769" y="541258"/>
+                </a:lnTo>
+                <a:lnTo>
+                  <a:pt x="840331" y="481447"/>
+                </a:lnTo>
+                <a:lnTo>
+                  <a:pt x="840331" y="481447"/>
+                </a:lnTo>
+                <a:lnTo>
+                  <a:pt x="855893" y="523288"/>
+                </a:lnTo>
+                <a:lnTo>
+                  <a:pt x="871454" y="530714"/>
+                </a:lnTo>
+                <a:lnTo>
+                  <a:pt x="887016" y="530732"/>
+                </a:lnTo>
+                <a:lnTo>
+                  <a:pt x="902578" y="525871"/>
+                </a:lnTo>
+                <a:lnTo>
+                  <a:pt x="918139" y="516886"/>
+                </a:lnTo>
+                <a:lnTo>
+                  <a:pt x="933701" y="503777"/>
+                </a:lnTo>
+                <a:lnTo>
+                  <a:pt x="949263" y="485790"/>
+                </a:lnTo>
+                <a:lnTo>
+                  <a:pt x="964824" y="460395"/>
+                </a:lnTo>
+                <a:lnTo>
                   <a:pt x="980386" y="400584"/>
-                </a:moveTo>
-                <a:lnTo>
-                  <a:pt x="980386" y="0"/>
-                </a:lnTo>
-                <a:lnTo>
-                  <a:pt x="0" y="566043"/>
-                </a:lnTo>
-                <a:lnTo>
-                  <a:pt x="0" y="966627"/>
                 </a:lnTo>
                 <a:close/>
               </a:path>
@@ -3164,7 +3368,7 @@
         <p:spPr>
           <a:xfrm>
             <a:off x="1022535" y="4491420"/>
-            <a:ext cx="1282044" cy="1140794"/>
+            <a:ext cx="1282044" cy="1190921"/>
           </a:xfrm>
           <a:custGeom>
             <a:avLst/>
@@ -3173,18 +3377,282 @@
             <a:cxnLst/>
             <a:rect l="l" t="t" r="r" b="b"/>
             <a:pathLst>
-              <a:path w="1282044" h="1140794">
+              <a:path w="1282044" h="1190921">
                 <a:moveTo>
+                  <a:pt x="1282044" y="740210"/>
+                </a:moveTo>
+                <a:lnTo>
+                  <a:pt x="0" y="0"/>
+                </a:lnTo>
+                <a:lnTo>
+                  <a:pt x="0" y="400584"/>
+                </a:lnTo>
+                <a:lnTo>
+                  <a:pt x="15828" y="461417"/>
+                </a:lnTo>
+                <a:lnTo>
+                  <a:pt x="31655" y="487246"/>
+                </a:lnTo>
+                <a:lnTo>
+                  <a:pt x="47483" y="505541"/>
+                </a:lnTo>
+                <a:lnTo>
+                  <a:pt x="63311" y="518874"/>
+                </a:lnTo>
+                <a:lnTo>
+                  <a:pt x="79138" y="528012"/>
+                </a:lnTo>
+                <a:lnTo>
+                  <a:pt x="94966" y="532956"/>
+                </a:lnTo>
+                <a:lnTo>
+                  <a:pt x="110794" y="532938"/>
+                </a:lnTo>
+                <a:lnTo>
+                  <a:pt x="126621" y="525386"/>
+                </a:lnTo>
+                <a:lnTo>
+                  <a:pt x="142449" y="482830"/>
+                </a:lnTo>
+                <a:lnTo>
+                  <a:pt x="142449" y="482830"/>
+                </a:lnTo>
+                <a:lnTo>
+                  <a:pt x="158277" y="543663"/>
+                </a:lnTo>
+                <a:lnTo>
+                  <a:pt x="174105" y="569492"/>
+                </a:lnTo>
+                <a:lnTo>
+                  <a:pt x="189932" y="587787"/>
+                </a:lnTo>
+                <a:lnTo>
+                  <a:pt x="205760" y="601120"/>
+                </a:lnTo>
+                <a:lnTo>
+                  <a:pt x="221588" y="610258"/>
+                </a:lnTo>
+                <a:lnTo>
+                  <a:pt x="237415" y="615202"/>
+                </a:lnTo>
+                <a:lnTo>
+                  <a:pt x="253243" y="615184"/>
+                </a:lnTo>
+                <a:lnTo>
+                  <a:pt x="269071" y="607631"/>
+                </a:lnTo>
+                <a:lnTo>
+                  <a:pt x="284899" y="565075"/>
+                </a:lnTo>
+                <a:lnTo>
+                  <a:pt x="284899" y="565075"/>
+                </a:lnTo>
+                <a:lnTo>
+                  <a:pt x="300726" y="625908"/>
+                </a:lnTo>
+                <a:lnTo>
+                  <a:pt x="316554" y="651737"/>
+                </a:lnTo>
+                <a:lnTo>
+                  <a:pt x="332382" y="670032"/>
+                </a:lnTo>
+                <a:lnTo>
+                  <a:pt x="348209" y="683365"/>
+                </a:lnTo>
+                <a:lnTo>
+                  <a:pt x="364037" y="692503"/>
+                </a:lnTo>
+                <a:lnTo>
+                  <a:pt x="379865" y="697447"/>
+                </a:lnTo>
+                <a:lnTo>
+                  <a:pt x="395692" y="697429"/>
+                </a:lnTo>
+                <a:lnTo>
+                  <a:pt x="411520" y="689877"/>
+                </a:lnTo>
+                <a:lnTo>
+                  <a:pt x="427348" y="647321"/>
+                </a:lnTo>
+                <a:lnTo>
+                  <a:pt x="427348" y="647321"/>
+                </a:lnTo>
+                <a:lnTo>
+                  <a:pt x="443176" y="708154"/>
+                </a:lnTo>
+                <a:lnTo>
+                  <a:pt x="459003" y="733983"/>
+                </a:lnTo>
+                <a:lnTo>
+                  <a:pt x="474831" y="752278"/>
+                </a:lnTo>
+                <a:lnTo>
+                  <a:pt x="490659" y="765611"/>
+                </a:lnTo>
+                <a:lnTo>
+                  <a:pt x="506486" y="774749"/>
+                </a:lnTo>
+                <a:lnTo>
+                  <a:pt x="522314" y="779693"/>
+                </a:lnTo>
+                <a:lnTo>
+                  <a:pt x="538142" y="779675"/>
+                </a:lnTo>
+                <a:lnTo>
+                  <a:pt x="553969" y="772122"/>
+                </a:lnTo>
+                <a:lnTo>
+                  <a:pt x="569797" y="729566"/>
+                </a:lnTo>
+                <a:lnTo>
+                  <a:pt x="569797" y="729566"/>
+                </a:lnTo>
+                <a:lnTo>
+                  <a:pt x="585625" y="790399"/>
+                </a:lnTo>
+                <a:lnTo>
+                  <a:pt x="601453" y="816229"/>
+                </a:lnTo>
+                <a:lnTo>
+                  <a:pt x="617280" y="834523"/>
+                </a:lnTo>
+                <a:lnTo>
+                  <a:pt x="633108" y="847856"/>
+                </a:lnTo>
+                <a:lnTo>
+                  <a:pt x="648936" y="856995"/>
+                </a:lnTo>
+                <a:lnTo>
+                  <a:pt x="664763" y="861939"/>
+                </a:lnTo>
+                <a:lnTo>
+                  <a:pt x="680591" y="861921"/>
+                </a:lnTo>
+                <a:lnTo>
+                  <a:pt x="696419" y="854368"/>
+                </a:lnTo>
+                <a:lnTo>
+                  <a:pt x="712246" y="811812"/>
+                </a:lnTo>
+                <a:lnTo>
+                  <a:pt x="712246" y="811812"/>
+                </a:lnTo>
+                <a:lnTo>
+                  <a:pt x="728074" y="872645"/>
+                </a:lnTo>
+                <a:lnTo>
+                  <a:pt x="743902" y="898474"/>
+                </a:lnTo>
+                <a:lnTo>
+                  <a:pt x="759730" y="916769"/>
+                </a:lnTo>
+                <a:lnTo>
+                  <a:pt x="775557" y="930102"/>
+                </a:lnTo>
+                <a:lnTo>
+                  <a:pt x="791385" y="939240"/>
+                </a:lnTo>
+                <a:lnTo>
+                  <a:pt x="807213" y="944184"/>
+                </a:lnTo>
+                <a:lnTo>
+                  <a:pt x="823040" y="944166"/>
+                </a:lnTo>
+                <a:lnTo>
+                  <a:pt x="838868" y="936614"/>
+                </a:lnTo>
+                <a:lnTo>
+                  <a:pt x="854696" y="894057"/>
+                </a:lnTo>
+                <a:lnTo>
+                  <a:pt x="854696" y="894057"/>
+                </a:lnTo>
+                <a:lnTo>
+                  <a:pt x="870523" y="954890"/>
+                </a:lnTo>
+                <a:lnTo>
+                  <a:pt x="886351" y="980720"/>
+                </a:lnTo>
+                <a:lnTo>
+                  <a:pt x="902179" y="999014"/>
+                </a:lnTo>
+                <a:lnTo>
+                  <a:pt x="918007" y="1012347"/>
+                </a:lnTo>
+                <a:lnTo>
+                  <a:pt x="933834" y="1021486"/>
+                </a:lnTo>
+                <a:lnTo>
+                  <a:pt x="949662" y="1026430"/>
+                </a:lnTo>
+                <a:lnTo>
+                  <a:pt x="965490" y="1026412"/>
+                </a:lnTo>
+                <a:lnTo>
+                  <a:pt x="981317" y="1018859"/>
+                </a:lnTo>
+                <a:lnTo>
+                  <a:pt x="997145" y="976303"/>
+                </a:lnTo>
+                <a:lnTo>
+                  <a:pt x="997145" y="976303"/>
+                </a:lnTo>
+                <a:lnTo>
+                  <a:pt x="1012973" y="1037136"/>
+                </a:lnTo>
+                <a:lnTo>
+                  <a:pt x="1028800" y="1062965"/>
+                </a:lnTo>
+                <a:lnTo>
+                  <a:pt x="1044628" y="1081260"/>
+                </a:lnTo>
+                <a:lnTo>
+                  <a:pt x="1060456" y="1094593"/>
+                </a:lnTo>
+                <a:lnTo>
+                  <a:pt x="1076284" y="1103731"/>
+                </a:lnTo>
+                <a:lnTo>
+                  <a:pt x="1092111" y="1108675"/>
+                </a:lnTo>
+                <a:lnTo>
+                  <a:pt x="1107939" y="1108657"/>
+                </a:lnTo>
+                <a:lnTo>
+                  <a:pt x="1123767" y="1101105"/>
+                </a:lnTo>
+                <a:lnTo>
+                  <a:pt x="1139594" y="1058549"/>
+                </a:lnTo>
+                <a:lnTo>
+                  <a:pt x="1139594" y="1058549"/>
+                </a:lnTo>
+                <a:lnTo>
+                  <a:pt x="1155422" y="1119382"/>
+                </a:lnTo>
+                <a:lnTo>
+                  <a:pt x="1171250" y="1145211"/>
+                </a:lnTo>
+                <a:lnTo>
+                  <a:pt x="1187077" y="1163506"/>
+                </a:lnTo>
+                <a:lnTo>
+                  <a:pt x="1202905" y="1176838"/>
+                </a:lnTo>
+                <a:lnTo>
+                  <a:pt x="1218733" y="1185977"/>
+                </a:lnTo>
+                <a:lnTo>
+                  <a:pt x="1234561" y="1190921"/>
+                </a:lnTo>
+                <a:lnTo>
+                  <a:pt x="1250388" y="1190903"/>
+                </a:lnTo>
+                <a:lnTo>
+                  <a:pt x="1266216" y="1183350"/>
+                </a:lnTo>
+                <a:lnTo>
                   <a:pt x="1282044" y="1140794"/>
-                </a:moveTo>
-                <a:lnTo>
-                  <a:pt x="1282044" y="740210"/>
-                </a:lnTo>
-                <a:lnTo>
-                  <a:pt x="0" y="0"/>
-                </a:lnTo>
-                <a:lnTo>
-                  <a:pt x="0" y="400584"/>
                 </a:lnTo>
                 <a:close/>
               </a:path>
@@ -5508,7 +5976,7 @@
         <p:spPr>
           <a:xfrm>
             <a:off x="7790841" y="4665587"/>
-            <a:ext cx="980387" cy="966627"/>
+            <a:ext cx="980387" cy="1015911"/>
           </a:xfrm>
           <a:custGeom>
             <a:avLst/>
@@ -5517,18 +5985,222 @@
             <a:cxnLst/>
             <a:rect l="l" t="t" r="r" b="b"/>
             <a:pathLst>
-              <a:path w="980387" h="966627">
+              <a:path w="980387" h="1015911">
                 <a:moveTo>
+                  <a:pt x="980387" y="0"/>
+                </a:moveTo>
+                <a:lnTo>
+                  <a:pt x="0" y="566043"/>
+                </a:lnTo>
+                <a:lnTo>
+                  <a:pt x="0" y="966627"/>
+                </a:lnTo>
+                <a:lnTo>
+                  <a:pt x="15562" y="1008468"/>
+                </a:lnTo>
+                <a:lnTo>
+                  <a:pt x="31124" y="1015894"/>
+                </a:lnTo>
+                <a:lnTo>
+                  <a:pt x="46686" y="1015911"/>
+                </a:lnTo>
+                <a:lnTo>
+                  <a:pt x="62247" y="1011050"/>
+                </a:lnTo>
+                <a:lnTo>
+                  <a:pt x="77809" y="1002066"/>
+                </a:lnTo>
+                <a:lnTo>
+                  <a:pt x="93371" y="988957"/>
+                </a:lnTo>
+                <a:lnTo>
+                  <a:pt x="108932" y="970970"/>
+                </a:lnTo>
+                <a:lnTo>
+                  <a:pt x="124494" y="945574"/>
+                </a:lnTo>
+                <a:lnTo>
+                  <a:pt x="140056" y="885764"/>
+                </a:lnTo>
+                <a:lnTo>
+                  <a:pt x="140056" y="885764"/>
+                </a:lnTo>
+                <a:lnTo>
+                  <a:pt x="155617" y="927605"/>
+                </a:lnTo>
+                <a:lnTo>
+                  <a:pt x="171179" y="935030"/>
+                </a:lnTo>
+                <a:lnTo>
+                  <a:pt x="186741" y="935048"/>
+                </a:lnTo>
+                <a:lnTo>
+                  <a:pt x="202302" y="930187"/>
+                </a:lnTo>
+                <a:lnTo>
+                  <a:pt x="217864" y="921202"/>
+                </a:lnTo>
+                <a:lnTo>
+                  <a:pt x="233426" y="908094"/>
+                </a:lnTo>
+                <a:lnTo>
+                  <a:pt x="248987" y="890106"/>
+                </a:lnTo>
+                <a:lnTo>
+                  <a:pt x="264549" y="864711"/>
+                </a:lnTo>
+                <a:lnTo>
+                  <a:pt x="280111" y="804901"/>
+                </a:lnTo>
+                <a:lnTo>
+                  <a:pt x="280111" y="804901"/>
+                </a:lnTo>
+                <a:lnTo>
+                  <a:pt x="295673" y="846741"/>
+                </a:lnTo>
+                <a:lnTo>
+                  <a:pt x="311234" y="854167"/>
+                </a:lnTo>
+                <a:lnTo>
+                  <a:pt x="326796" y="854185"/>
+                </a:lnTo>
+                <a:lnTo>
+                  <a:pt x="342358" y="849324"/>
+                </a:lnTo>
+                <a:lnTo>
+                  <a:pt x="357919" y="840339"/>
+                </a:lnTo>
+                <a:lnTo>
+                  <a:pt x="373481" y="827230"/>
+                </a:lnTo>
+                <a:lnTo>
+                  <a:pt x="389043" y="809243"/>
+                </a:lnTo>
+                <a:lnTo>
+                  <a:pt x="404604" y="783848"/>
+                </a:lnTo>
+                <a:lnTo>
+                  <a:pt x="420166" y="724037"/>
+                </a:lnTo>
+                <a:lnTo>
+                  <a:pt x="420166" y="724037"/>
+                </a:lnTo>
+                <a:lnTo>
+                  <a:pt x="435728" y="765878"/>
+                </a:lnTo>
+                <a:lnTo>
+                  <a:pt x="451289" y="773304"/>
+                </a:lnTo>
+                <a:lnTo>
+                  <a:pt x="466851" y="773321"/>
+                </a:lnTo>
+                <a:lnTo>
+                  <a:pt x="482413" y="768461"/>
+                </a:lnTo>
+                <a:lnTo>
+                  <a:pt x="497975" y="759476"/>
+                </a:lnTo>
+                <a:lnTo>
+                  <a:pt x="513536" y="746367"/>
+                </a:lnTo>
+                <a:lnTo>
+                  <a:pt x="529098" y="728380"/>
+                </a:lnTo>
+                <a:lnTo>
+                  <a:pt x="544660" y="702985"/>
+                </a:lnTo>
+                <a:lnTo>
+                  <a:pt x="560221" y="643174"/>
+                </a:lnTo>
+                <a:lnTo>
+                  <a:pt x="560221" y="643174"/>
+                </a:lnTo>
+                <a:lnTo>
+                  <a:pt x="575783" y="685015"/>
+                </a:lnTo>
+                <a:lnTo>
+                  <a:pt x="591345" y="692441"/>
+                </a:lnTo>
+                <a:lnTo>
+                  <a:pt x="606906" y="692458"/>
+                </a:lnTo>
+                <a:lnTo>
+                  <a:pt x="622468" y="687597"/>
+                </a:lnTo>
+                <a:lnTo>
+                  <a:pt x="638030" y="678613"/>
+                </a:lnTo>
+                <a:lnTo>
+                  <a:pt x="653591" y="665504"/>
+                </a:lnTo>
+                <a:lnTo>
+                  <a:pt x="669153" y="647516"/>
+                </a:lnTo>
+                <a:lnTo>
+                  <a:pt x="684715" y="622121"/>
+                </a:lnTo>
+                <a:lnTo>
+                  <a:pt x="700276" y="562311"/>
+                </a:lnTo>
+                <a:lnTo>
+                  <a:pt x="700276" y="562311"/>
+                </a:lnTo>
+                <a:lnTo>
+                  <a:pt x="715838" y="604152"/>
+                </a:lnTo>
+                <a:lnTo>
+                  <a:pt x="731400" y="611577"/>
+                </a:lnTo>
+                <a:lnTo>
+                  <a:pt x="746962" y="611595"/>
+                </a:lnTo>
+                <a:lnTo>
+                  <a:pt x="762523" y="606734"/>
+                </a:lnTo>
+                <a:lnTo>
+                  <a:pt x="778085" y="597749"/>
+                </a:lnTo>
+                <a:lnTo>
+                  <a:pt x="793647" y="584640"/>
+                </a:lnTo>
+                <a:lnTo>
+                  <a:pt x="809208" y="566653"/>
+                </a:lnTo>
+                <a:lnTo>
+                  <a:pt x="824770" y="541258"/>
+                </a:lnTo>
+                <a:lnTo>
+                  <a:pt x="840332" y="481447"/>
+                </a:lnTo>
+                <a:lnTo>
+                  <a:pt x="840332" y="481447"/>
+                </a:lnTo>
+                <a:lnTo>
+                  <a:pt x="855893" y="523288"/>
+                </a:lnTo>
+                <a:lnTo>
+                  <a:pt x="871455" y="530714"/>
+                </a:lnTo>
+                <a:lnTo>
+                  <a:pt x="887017" y="530732"/>
+                </a:lnTo>
+                <a:lnTo>
+                  <a:pt x="902578" y="525871"/>
+                </a:lnTo>
+                <a:lnTo>
+                  <a:pt x="918140" y="516886"/>
+                </a:lnTo>
+                <a:lnTo>
+                  <a:pt x="933702" y="503777"/>
+                </a:lnTo>
+                <a:lnTo>
+                  <a:pt x="949264" y="485790"/>
+                </a:lnTo>
+                <a:lnTo>
+                  <a:pt x="964825" y="460395"/>
+                </a:lnTo>
+                <a:lnTo>
                   <a:pt x="980387" y="400584"/>
-                </a:moveTo>
-                <a:lnTo>
-                  <a:pt x="980387" y="0"/>
-                </a:lnTo>
-                <a:lnTo>
-                  <a:pt x="0" y="566043"/>
-                </a:lnTo>
-                <a:lnTo>
-                  <a:pt x="0" y="966627"/>
                 </a:lnTo>
                 <a:close/>
               </a:path>
@@ -5575,7 +6247,7 @@
         <p:spPr>
           <a:xfrm>
             <a:off x="6508798" y="4491420"/>
-            <a:ext cx="1282043" cy="1140794"/>
+            <a:ext cx="1282043" cy="1190921"/>
           </a:xfrm>
           <a:custGeom>
             <a:avLst/>
@@ -5584,18 +6256,282 @@
             <a:cxnLst/>
             <a:rect l="l" t="t" r="r" b="b"/>
             <a:pathLst>
-              <a:path w="1282043" h="1140794">
+              <a:path w="1282043" h="1190921">
                 <a:moveTo>
+                  <a:pt x="1282043" y="740210"/>
+                </a:moveTo>
+                <a:lnTo>
+                  <a:pt x="0" y="0"/>
+                </a:lnTo>
+                <a:lnTo>
+                  <a:pt x="0" y="400584"/>
+                </a:lnTo>
+                <a:lnTo>
+                  <a:pt x="15827" y="461417"/>
+                </a:lnTo>
+                <a:lnTo>
+                  <a:pt x="31655" y="487246"/>
+                </a:lnTo>
+                <a:lnTo>
+                  <a:pt x="47483" y="505541"/>
+                </a:lnTo>
+                <a:lnTo>
+                  <a:pt x="63310" y="518874"/>
+                </a:lnTo>
+                <a:lnTo>
+                  <a:pt x="79138" y="528012"/>
+                </a:lnTo>
+                <a:lnTo>
+                  <a:pt x="94966" y="532956"/>
+                </a:lnTo>
+                <a:lnTo>
+                  <a:pt x="110794" y="532938"/>
+                </a:lnTo>
+                <a:lnTo>
+                  <a:pt x="126621" y="525386"/>
+                </a:lnTo>
+                <a:lnTo>
+                  <a:pt x="142449" y="482830"/>
+                </a:lnTo>
+                <a:lnTo>
+                  <a:pt x="142449" y="482830"/>
+                </a:lnTo>
+                <a:lnTo>
+                  <a:pt x="158277" y="543663"/>
+                </a:lnTo>
+                <a:lnTo>
+                  <a:pt x="174104" y="569492"/>
+                </a:lnTo>
+                <a:lnTo>
+                  <a:pt x="189932" y="587787"/>
+                </a:lnTo>
+                <a:lnTo>
+                  <a:pt x="205760" y="601120"/>
+                </a:lnTo>
+                <a:lnTo>
+                  <a:pt x="221587" y="610258"/>
+                </a:lnTo>
+                <a:lnTo>
+                  <a:pt x="237415" y="615202"/>
+                </a:lnTo>
+                <a:lnTo>
+                  <a:pt x="253243" y="615184"/>
+                </a:lnTo>
+                <a:lnTo>
+                  <a:pt x="269071" y="607631"/>
+                </a:lnTo>
+                <a:lnTo>
+                  <a:pt x="284898" y="565075"/>
+                </a:lnTo>
+                <a:lnTo>
+                  <a:pt x="284898" y="565075"/>
+                </a:lnTo>
+                <a:lnTo>
+                  <a:pt x="300726" y="625908"/>
+                </a:lnTo>
+                <a:lnTo>
+                  <a:pt x="316554" y="651737"/>
+                </a:lnTo>
+                <a:lnTo>
+                  <a:pt x="332381" y="670032"/>
+                </a:lnTo>
+                <a:lnTo>
+                  <a:pt x="348209" y="683365"/>
+                </a:lnTo>
+                <a:lnTo>
+                  <a:pt x="364037" y="692503"/>
+                </a:lnTo>
+                <a:lnTo>
+                  <a:pt x="379864" y="697447"/>
+                </a:lnTo>
+                <a:lnTo>
+                  <a:pt x="395692" y="697429"/>
+                </a:lnTo>
+                <a:lnTo>
+                  <a:pt x="411520" y="689877"/>
+                </a:lnTo>
+                <a:lnTo>
+                  <a:pt x="427348" y="647321"/>
+                </a:lnTo>
+                <a:lnTo>
+                  <a:pt x="427348" y="647321"/>
+                </a:lnTo>
+                <a:lnTo>
+                  <a:pt x="443175" y="708154"/>
+                </a:lnTo>
+                <a:lnTo>
+                  <a:pt x="459003" y="733983"/>
+                </a:lnTo>
+                <a:lnTo>
+                  <a:pt x="474831" y="752278"/>
+                </a:lnTo>
+                <a:lnTo>
+                  <a:pt x="490658" y="765611"/>
+                </a:lnTo>
+                <a:lnTo>
+                  <a:pt x="506486" y="774749"/>
+                </a:lnTo>
+                <a:lnTo>
+                  <a:pt x="522314" y="779693"/>
+                </a:lnTo>
+                <a:lnTo>
+                  <a:pt x="538141" y="779675"/>
+                </a:lnTo>
+                <a:lnTo>
+                  <a:pt x="553969" y="772122"/>
+                </a:lnTo>
+                <a:lnTo>
+                  <a:pt x="569797" y="729566"/>
+                </a:lnTo>
+                <a:lnTo>
+                  <a:pt x="569797" y="729566"/>
+                </a:lnTo>
+                <a:lnTo>
+                  <a:pt x="585625" y="790399"/>
+                </a:lnTo>
+                <a:lnTo>
+                  <a:pt x="601452" y="816229"/>
+                </a:lnTo>
+                <a:lnTo>
+                  <a:pt x="617280" y="834523"/>
+                </a:lnTo>
+                <a:lnTo>
+                  <a:pt x="633108" y="847856"/>
+                </a:lnTo>
+                <a:lnTo>
+                  <a:pt x="648935" y="856995"/>
+                </a:lnTo>
+                <a:lnTo>
+                  <a:pt x="664763" y="861939"/>
+                </a:lnTo>
+                <a:lnTo>
+                  <a:pt x="680591" y="861921"/>
+                </a:lnTo>
+                <a:lnTo>
+                  <a:pt x="696418" y="854368"/>
+                </a:lnTo>
+                <a:lnTo>
+                  <a:pt x="712246" y="811812"/>
+                </a:lnTo>
+                <a:lnTo>
+                  <a:pt x="712246" y="811812"/>
+                </a:lnTo>
+                <a:lnTo>
+                  <a:pt x="728074" y="872645"/>
+                </a:lnTo>
+                <a:lnTo>
+                  <a:pt x="743902" y="898474"/>
+                </a:lnTo>
+                <a:lnTo>
+                  <a:pt x="759729" y="916769"/>
+                </a:lnTo>
+                <a:lnTo>
+                  <a:pt x="775557" y="930102"/>
+                </a:lnTo>
+                <a:lnTo>
+                  <a:pt x="791385" y="939240"/>
+                </a:lnTo>
+                <a:lnTo>
+                  <a:pt x="807212" y="944184"/>
+                </a:lnTo>
+                <a:lnTo>
+                  <a:pt x="823040" y="944166"/>
+                </a:lnTo>
+                <a:lnTo>
+                  <a:pt x="838868" y="936614"/>
+                </a:lnTo>
+                <a:lnTo>
+                  <a:pt x="854696" y="894057"/>
+                </a:lnTo>
+                <a:lnTo>
+                  <a:pt x="854696" y="894057"/>
+                </a:lnTo>
+                <a:lnTo>
+                  <a:pt x="870523" y="954890"/>
+                </a:lnTo>
+                <a:lnTo>
+                  <a:pt x="886351" y="980720"/>
+                </a:lnTo>
+                <a:lnTo>
+                  <a:pt x="902179" y="999014"/>
+                </a:lnTo>
+                <a:lnTo>
+                  <a:pt x="918006" y="1012347"/>
+                </a:lnTo>
+                <a:lnTo>
+                  <a:pt x="933834" y="1021486"/>
+                </a:lnTo>
+                <a:lnTo>
+                  <a:pt x="949662" y="1026430"/>
+                </a:lnTo>
+                <a:lnTo>
+                  <a:pt x="965489" y="1026412"/>
+                </a:lnTo>
+                <a:lnTo>
+                  <a:pt x="981317" y="1018859"/>
+                </a:lnTo>
+                <a:lnTo>
+                  <a:pt x="997145" y="976303"/>
+                </a:lnTo>
+                <a:lnTo>
+                  <a:pt x="997145" y="976303"/>
+                </a:lnTo>
+                <a:lnTo>
+                  <a:pt x="1012973" y="1037136"/>
+                </a:lnTo>
+                <a:lnTo>
+                  <a:pt x="1028800" y="1062965"/>
+                </a:lnTo>
+                <a:lnTo>
+                  <a:pt x="1044628" y="1081260"/>
+                </a:lnTo>
+                <a:lnTo>
+                  <a:pt x="1060456" y="1094593"/>
+                </a:lnTo>
+                <a:lnTo>
+                  <a:pt x="1076283" y="1103731"/>
+                </a:lnTo>
+                <a:lnTo>
+                  <a:pt x="1092111" y="1108675"/>
+                </a:lnTo>
+                <a:lnTo>
+                  <a:pt x="1107939" y="1108657"/>
+                </a:lnTo>
+                <a:lnTo>
+                  <a:pt x="1123766" y="1101105"/>
+                </a:lnTo>
+                <a:lnTo>
+                  <a:pt x="1139594" y="1058549"/>
+                </a:lnTo>
+                <a:lnTo>
+                  <a:pt x="1139594" y="1058549"/>
+                </a:lnTo>
+                <a:lnTo>
+                  <a:pt x="1155422" y="1119382"/>
+                </a:lnTo>
+                <a:lnTo>
+                  <a:pt x="1171250" y="1145211"/>
+                </a:lnTo>
+                <a:lnTo>
+                  <a:pt x="1187077" y="1163506"/>
+                </a:lnTo>
+                <a:lnTo>
+                  <a:pt x="1202905" y="1176838"/>
+                </a:lnTo>
+                <a:lnTo>
+                  <a:pt x="1218733" y="1185977"/>
+                </a:lnTo>
+                <a:lnTo>
+                  <a:pt x="1234560" y="1190921"/>
+                </a:lnTo>
+                <a:lnTo>
+                  <a:pt x="1250388" y="1190903"/>
+                </a:lnTo>
+                <a:lnTo>
+                  <a:pt x="1266216" y="1183350"/>
+                </a:lnTo>
+                <a:lnTo>
                   <a:pt x="1282043" y="1140794"/>
-                </a:moveTo>
-                <a:lnTo>
-                  <a:pt x="1282043" y="740210"/>
-                </a:lnTo>
-                <a:lnTo>
-                  <a:pt x="0" y="0"/>
-                </a:lnTo>
-                <a:lnTo>
-                  <a:pt x="0" y="400584"/>
                 </a:lnTo>
                 <a:close/>
               </a:path>
@@ -8205,7 +9141,7 @@
         </p:nvCxnSpPr>
         <p:spPr>
           <a:xfrm flipH="1">
-            <a:off x="1286677" y="5362255"/>
+            <a:off x="1286677" y="5444501"/>
             <a:ext cx="505084" cy="374459"/>
           </a:xfrm>
           <a:prstGeom prst="line">
@@ -8242,7 +9178,7 @@
         </p:nvCxnSpPr>
         <p:spPr>
           <a:xfrm>
-            <a:off x="2304579" y="5658339"/>
+            <a:off x="2304579" y="5740585"/>
             <a:ext cx="0" cy="566043"/>
           </a:xfrm>
           <a:prstGeom prst="line">
@@ -8279,7 +9215,7 @@
         </p:nvCxnSpPr>
         <p:spPr>
           <a:xfrm>
-            <a:off x="2696733" y="5431922"/>
+            <a:off x="2696733" y="5512785"/>
             <a:ext cx="505085" cy="374459"/>
           </a:xfrm>
           <a:prstGeom prst="line">
@@ -8316,7 +9252,7 @@
         </p:nvSpPr>
         <p:spPr>
           <a:xfrm>
-            <a:off x="998326" y="6327576"/>
+            <a:off x="998326" y="6409822"/>
             <a:ext cx="2612506" cy="350947"/>
           </a:xfrm>
           <a:prstGeom prst="rect">
@@ -8351,7 +9287,7 @@
         </p:nvCxnSpPr>
         <p:spPr>
           <a:xfrm flipH="1">
-            <a:off x="6772939" y="5362255"/>
+            <a:off x="6772939" y="5444501"/>
             <a:ext cx="505085" cy="374459"/>
           </a:xfrm>
           <a:prstGeom prst="line">
@@ -8388,7 +9324,7 @@
         </p:nvCxnSpPr>
         <p:spPr>
           <a:xfrm>
-            <a:off x="7790841" y="5658339"/>
+            <a:off x="7790841" y="5740585"/>
             <a:ext cx="0" cy="566043"/>
           </a:xfrm>
           <a:prstGeom prst="line">
@@ -8425,7 +9361,7 @@
         </p:nvCxnSpPr>
         <p:spPr>
           <a:xfrm>
-            <a:off x="8182996" y="5431922"/>
+            <a:off x="8182996" y="5512785"/>
             <a:ext cx="505085" cy="374459"/>
           </a:xfrm>
           <a:prstGeom prst="line">
@@ -8462,7 +9398,7 @@
         </p:nvSpPr>
         <p:spPr>
           <a:xfrm>
-            <a:off x="6484588" y="6327576"/>
+            <a:off x="6484588" y="6409822"/>
             <a:ext cx="2612506" cy="350947"/>
           </a:xfrm>
           <a:prstGeom prst="rect">

</xml_diff>

<commit_message>
Make each layer a square film rather than a rectangle
BW and BD are both 150 now, so every layer is a square seen corner-on and
the two visible side faces are mirror images. BW + BD is unchanged, so the
figure keeps its screen footprint and nothing in the layout moves.

It also makes the micro-lens array consistent: the two bottom edges are
now the same length, so both carry the same lens pitch instead of two
slightly different ones.

Co-Authored-By: Claude Opus 5 <noreply@anthropic.com>
Claude-Session: https://claude.ai/code/session_014A61zHZtLZU5uPXAWC8gtS
</commit_message>
<xml_diff>
--- a/figures/device_stacks.pptx
+++ b/figures/device_stacks.pptx
@@ -3096,8 +3096,8 @@
         </p:nvSpPr>
         <p:spPr>
           <a:xfrm>
-            <a:off x="2304579" y="4665587"/>
-            <a:ext cx="980386" cy="1015911"/>
+            <a:off x="2002921" y="4578503"/>
+            <a:ext cx="1131215" cy="1103469"/>
           </a:xfrm>
           <a:custGeom>
             <a:avLst/>
@@ -3106,222 +3106,252 @@
             <a:cxnLst/>
             <a:rect l="l" t="t" r="r" b="b"/>
             <a:pathLst>
-              <a:path w="980386" h="1015911">
+              <a:path w="1131215" h="1103469">
                 <a:moveTo>
-                  <a:pt x="980386" y="0"/>
+                  <a:pt x="1131215" y="0"/>
                 </a:moveTo>
                 <a:lnTo>
-                  <a:pt x="0" y="566043"/>
-                </a:lnTo>
-                <a:lnTo>
-                  <a:pt x="0" y="966627"/>
-                </a:lnTo>
-                <a:lnTo>
-                  <a:pt x="15561" y="1008468"/>
-                </a:lnTo>
-                <a:lnTo>
-                  <a:pt x="31123" y="1015894"/>
-                </a:lnTo>
-                <a:lnTo>
-                  <a:pt x="46685" y="1015911"/>
-                </a:lnTo>
-                <a:lnTo>
-                  <a:pt x="62246" y="1011050"/>
-                </a:lnTo>
-                <a:lnTo>
-                  <a:pt x="77808" y="1002066"/>
-                </a:lnTo>
-                <a:lnTo>
-                  <a:pt x="93370" y="988957"/>
-                </a:lnTo>
-                <a:lnTo>
-                  <a:pt x="108932" y="970970"/>
-                </a:lnTo>
-                <a:lnTo>
-                  <a:pt x="124493" y="945574"/>
-                </a:lnTo>
-                <a:lnTo>
-                  <a:pt x="140055" y="885764"/>
-                </a:lnTo>
-                <a:lnTo>
-                  <a:pt x="140055" y="885764"/>
-                </a:lnTo>
-                <a:lnTo>
-                  <a:pt x="155617" y="927605"/>
-                </a:lnTo>
-                <a:lnTo>
-                  <a:pt x="171178" y="935030"/>
-                </a:lnTo>
-                <a:lnTo>
-                  <a:pt x="186740" y="935048"/>
-                </a:lnTo>
-                <a:lnTo>
-                  <a:pt x="202302" y="930187"/>
-                </a:lnTo>
-                <a:lnTo>
-                  <a:pt x="217863" y="921202"/>
-                </a:lnTo>
-                <a:lnTo>
-                  <a:pt x="233425" y="908094"/>
-                </a:lnTo>
-                <a:lnTo>
-                  <a:pt x="248987" y="890106"/>
-                </a:lnTo>
-                <a:lnTo>
-                  <a:pt x="264548" y="864711"/>
-                </a:lnTo>
-                <a:lnTo>
-                  <a:pt x="280110" y="804901"/>
-                </a:lnTo>
-                <a:lnTo>
-                  <a:pt x="280110" y="804901"/>
-                </a:lnTo>
-                <a:lnTo>
-                  <a:pt x="295672" y="846741"/>
-                </a:lnTo>
-                <a:lnTo>
-                  <a:pt x="311233" y="854167"/>
-                </a:lnTo>
-                <a:lnTo>
-                  <a:pt x="326795" y="854185"/>
-                </a:lnTo>
-                <a:lnTo>
-                  <a:pt x="342357" y="849324"/>
-                </a:lnTo>
-                <a:lnTo>
-                  <a:pt x="357919" y="840339"/>
-                </a:lnTo>
-                <a:lnTo>
-                  <a:pt x="373480" y="827230"/>
-                </a:lnTo>
-                <a:lnTo>
-                  <a:pt x="389042" y="809243"/>
-                </a:lnTo>
-                <a:lnTo>
-                  <a:pt x="404604" y="783848"/>
-                </a:lnTo>
-                <a:lnTo>
-                  <a:pt x="420165" y="724037"/>
-                </a:lnTo>
-                <a:lnTo>
-                  <a:pt x="420165" y="724037"/>
-                </a:lnTo>
-                <a:lnTo>
-                  <a:pt x="435727" y="765878"/>
-                </a:lnTo>
-                <a:lnTo>
-                  <a:pt x="451289" y="773304"/>
-                </a:lnTo>
-                <a:lnTo>
-                  <a:pt x="466850" y="773321"/>
-                </a:lnTo>
-                <a:lnTo>
-                  <a:pt x="482412" y="768461"/>
-                </a:lnTo>
-                <a:lnTo>
-                  <a:pt x="497974" y="759476"/>
-                </a:lnTo>
-                <a:lnTo>
-                  <a:pt x="513535" y="746367"/>
-                </a:lnTo>
-                <a:lnTo>
-                  <a:pt x="529097" y="728380"/>
-                </a:lnTo>
-                <a:lnTo>
-                  <a:pt x="544659" y="702985"/>
-                </a:lnTo>
-                <a:lnTo>
-                  <a:pt x="560221" y="643174"/>
-                </a:lnTo>
-                <a:lnTo>
-                  <a:pt x="560221" y="643174"/>
-                </a:lnTo>
-                <a:lnTo>
-                  <a:pt x="575782" y="685015"/>
-                </a:lnTo>
-                <a:lnTo>
-                  <a:pt x="591344" y="692441"/>
-                </a:lnTo>
-                <a:lnTo>
-                  <a:pt x="606906" y="692458"/>
-                </a:lnTo>
-                <a:lnTo>
-                  <a:pt x="622467" y="687597"/>
-                </a:lnTo>
-                <a:lnTo>
-                  <a:pt x="638029" y="678613"/>
-                </a:lnTo>
-                <a:lnTo>
-                  <a:pt x="653591" y="665504"/>
-                </a:lnTo>
-                <a:lnTo>
-                  <a:pt x="669152" y="647516"/>
-                </a:lnTo>
-                <a:lnTo>
-                  <a:pt x="684714" y="622121"/>
-                </a:lnTo>
-                <a:lnTo>
-                  <a:pt x="700276" y="562311"/>
-                </a:lnTo>
-                <a:lnTo>
-                  <a:pt x="700276" y="562311"/>
-                </a:lnTo>
-                <a:lnTo>
-                  <a:pt x="715837" y="604152"/>
-                </a:lnTo>
-                <a:lnTo>
-                  <a:pt x="731399" y="611577"/>
-                </a:lnTo>
-                <a:lnTo>
-                  <a:pt x="746961" y="611595"/>
-                </a:lnTo>
-                <a:lnTo>
-                  <a:pt x="762522" y="606734"/>
-                </a:lnTo>
-                <a:lnTo>
-                  <a:pt x="778084" y="597749"/>
-                </a:lnTo>
-                <a:lnTo>
-                  <a:pt x="793646" y="584640"/>
-                </a:lnTo>
-                <a:lnTo>
-                  <a:pt x="809208" y="566653"/>
-                </a:lnTo>
-                <a:lnTo>
-                  <a:pt x="824769" y="541258"/>
-                </a:lnTo>
-                <a:lnTo>
-                  <a:pt x="840331" y="481447"/>
-                </a:lnTo>
-                <a:lnTo>
-                  <a:pt x="840331" y="481447"/>
-                </a:lnTo>
-                <a:lnTo>
-                  <a:pt x="855893" y="523288"/>
-                </a:lnTo>
-                <a:lnTo>
-                  <a:pt x="871454" y="530714"/>
-                </a:lnTo>
-                <a:lnTo>
-                  <a:pt x="887016" y="530732"/>
-                </a:lnTo>
-                <a:lnTo>
-                  <a:pt x="902578" y="525871"/>
-                </a:lnTo>
-                <a:lnTo>
-                  <a:pt x="918139" y="516886"/>
-                </a:lnTo>
-                <a:lnTo>
-                  <a:pt x="933701" y="503777"/>
-                </a:lnTo>
-                <a:lnTo>
-                  <a:pt x="949263" y="485790"/>
-                </a:lnTo>
-                <a:lnTo>
-                  <a:pt x="964824" y="460395"/>
-                </a:lnTo>
-                <a:lnTo>
-                  <a:pt x="980386" y="400584"/>
+                  <a:pt x="0" y="653127"/>
+                </a:lnTo>
+                <a:lnTo>
+                  <a:pt x="0" y="1053711"/>
+                </a:lnTo>
+                <a:lnTo>
+                  <a:pt x="15712" y="1095954"/>
+                </a:lnTo>
+                <a:lnTo>
+                  <a:pt x="31423" y="1103451"/>
+                </a:lnTo>
+                <a:lnTo>
+                  <a:pt x="47134" y="1103469"/>
+                </a:lnTo>
+                <a:lnTo>
+                  <a:pt x="62846" y="1098562"/>
+                </a:lnTo>
+                <a:lnTo>
+                  <a:pt x="78557" y="1089490"/>
+                </a:lnTo>
+                <a:lnTo>
+                  <a:pt x="94268" y="1076256"/>
+                </a:lnTo>
+                <a:lnTo>
+                  <a:pt x="109980" y="1058095"/>
+                </a:lnTo>
+                <a:lnTo>
+                  <a:pt x="125691" y="1032456"/>
+                </a:lnTo>
+                <a:lnTo>
+                  <a:pt x="141402" y="972070"/>
+                </a:lnTo>
+                <a:lnTo>
+                  <a:pt x="141402" y="972070"/>
+                </a:lnTo>
+                <a:lnTo>
+                  <a:pt x="157114" y="1014314"/>
+                </a:lnTo>
+                <a:lnTo>
+                  <a:pt x="172825" y="1021811"/>
+                </a:lnTo>
+                <a:lnTo>
+                  <a:pt x="188536" y="1021828"/>
+                </a:lnTo>
+                <a:lnTo>
+                  <a:pt x="204247" y="1016921"/>
+                </a:lnTo>
+                <a:lnTo>
+                  <a:pt x="219959" y="1007850"/>
+                </a:lnTo>
+                <a:lnTo>
+                  <a:pt x="235670" y="994615"/>
+                </a:lnTo>
+                <a:lnTo>
+                  <a:pt x="251381" y="976455"/>
+                </a:lnTo>
+                <a:lnTo>
+                  <a:pt x="267093" y="950815"/>
+                </a:lnTo>
+                <a:lnTo>
+                  <a:pt x="282804" y="890429"/>
+                </a:lnTo>
+                <a:lnTo>
+                  <a:pt x="282804" y="890429"/>
+                </a:lnTo>
+                <a:lnTo>
+                  <a:pt x="298515" y="932673"/>
+                </a:lnTo>
+                <a:lnTo>
+                  <a:pt x="314227" y="940170"/>
+                </a:lnTo>
+                <a:lnTo>
+                  <a:pt x="329938" y="940188"/>
+                </a:lnTo>
+                <a:lnTo>
+                  <a:pt x="345649" y="935280"/>
+                </a:lnTo>
+                <a:lnTo>
+                  <a:pt x="361361" y="926209"/>
+                </a:lnTo>
+                <a:lnTo>
+                  <a:pt x="377072" y="912974"/>
+                </a:lnTo>
+                <a:lnTo>
+                  <a:pt x="392783" y="894814"/>
+                </a:lnTo>
+                <a:lnTo>
+                  <a:pt x="408495" y="869174"/>
+                </a:lnTo>
+                <a:lnTo>
+                  <a:pt x="424206" y="808789"/>
+                </a:lnTo>
+                <a:lnTo>
+                  <a:pt x="424206" y="808789"/>
+                </a:lnTo>
+                <a:lnTo>
+                  <a:pt x="439917" y="851032"/>
+                </a:lnTo>
+                <a:lnTo>
+                  <a:pt x="455629" y="858529"/>
+                </a:lnTo>
+                <a:lnTo>
+                  <a:pt x="471340" y="858547"/>
+                </a:lnTo>
+                <a:lnTo>
+                  <a:pt x="487051" y="853639"/>
+                </a:lnTo>
+                <a:lnTo>
+                  <a:pt x="502763" y="844568"/>
+                </a:lnTo>
+                <a:lnTo>
+                  <a:pt x="518474" y="831333"/>
+                </a:lnTo>
+                <a:lnTo>
+                  <a:pt x="534185" y="813173"/>
+                </a:lnTo>
+                <a:lnTo>
+                  <a:pt x="549897" y="787534"/>
+                </a:lnTo>
+                <a:lnTo>
+                  <a:pt x="565608" y="727148"/>
+                </a:lnTo>
+                <a:lnTo>
+                  <a:pt x="565608" y="727148"/>
+                </a:lnTo>
+                <a:lnTo>
+                  <a:pt x="581319" y="769391"/>
+                </a:lnTo>
+                <a:lnTo>
+                  <a:pt x="597031" y="776888"/>
+                </a:lnTo>
+                <a:lnTo>
+                  <a:pt x="612742" y="776906"/>
+                </a:lnTo>
+                <a:lnTo>
+                  <a:pt x="628453" y="771998"/>
+                </a:lnTo>
+                <a:lnTo>
+                  <a:pt x="644164" y="762927"/>
+                </a:lnTo>
+                <a:lnTo>
+                  <a:pt x="659876" y="749692"/>
+                </a:lnTo>
+                <a:lnTo>
+                  <a:pt x="675587" y="731532"/>
+                </a:lnTo>
+                <a:lnTo>
+                  <a:pt x="691298" y="705893"/>
+                </a:lnTo>
+                <a:lnTo>
+                  <a:pt x="707010" y="645507"/>
+                </a:lnTo>
+                <a:lnTo>
+                  <a:pt x="707010" y="645507"/>
+                </a:lnTo>
+                <a:lnTo>
+                  <a:pt x="722721" y="687750"/>
+                </a:lnTo>
+                <a:lnTo>
+                  <a:pt x="738432" y="695247"/>
+                </a:lnTo>
+                <a:lnTo>
+                  <a:pt x="754144" y="695265"/>
+                </a:lnTo>
+                <a:lnTo>
+                  <a:pt x="769855" y="690358"/>
+                </a:lnTo>
+                <a:lnTo>
+                  <a:pt x="785566" y="681286"/>
+                </a:lnTo>
+                <a:lnTo>
+                  <a:pt x="801278" y="668052"/>
+                </a:lnTo>
+                <a:lnTo>
+                  <a:pt x="816989" y="649891"/>
+                </a:lnTo>
+                <a:lnTo>
+                  <a:pt x="832700" y="624252"/>
+                </a:lnTo>
+                <a:lnTo>
+                  <a:pt x="848412" y="563866"/>
+                </a:lnTo>
+                <a:lnTo>
+                  <a:pt x="848412" y="563866"/>
+                </a:lnTo>
+                <a:lnTo>
+                  <a:pt x="864123" y="606109"/>
+                </a:lnTo>
+                <a:lnTo>
+                  <a:pt x="879834" y="613606"/>
+                </a:lnTo>
+                <a:lnTo>
+                  <a:pt x="895546" y="613624"/>
+                </a:lnTo>
+                <a:lnTo>
+                  <a:pt x="911257" y="608717"/>
+                </a:lnTo>
+                <a:lnTo>
+                  <a:pt x="926968" y="599646"/>
+                </a:lnTo>
+                <a:lnTo>
+                  <a:pt x="942680" y="586411"/>
+                </a:lnTo>
+                <a:lnTo>
+                  <a:pt x="958391" y="568250"/>
+                </a:lnTo>
+                <a:lnTo>
+                  <a:pt x="974102" y="542611"/>
+                </a:lnTo>
+                <a:lnTo>
+                  <a:pt x="989814" y="482225"/>
+                </a:lnTo>
+                <a:lnTo>
+                  <a:pt x="989814" y="482225"/>
+                </a:lnTo>
+                <a:lnTo>
+                  <a:pt x="1005525" y="524469"/>
+                </a:lnTo>
+                <a:lnTo>
+                  <a:pt x="1021236" y="531966"/>
+                </a:lnTo>
+                <a:lnTo>
+                  <a:pt x="1036948" y="531984"/>
+                </a:lnTo>
+                <a:lnTo>
+                  <a:pt x="1052659" y="527076"/>
+                </a:lnTo>
+                <a:lnTo>
+                  <a:pt x="1068370" y="518005"/>
+                </a:lnTo>
+                <a:lnTo>
+                  <a:pt x="1084081" y="504770"/>
+                </a:lnTo>
+                <a:lnTo>
+                  <a:pt x="1099793" y="486610"/>
+                </a:lnTo>
+                <a:lnTo>
+                  <a:pt x="1115504" y="460970"/>
+                </a:lnTo>
+                <a:lnTo>
+                  <a:pt x="1131215" y="400585"/>
                 </a:lnTo>
                 <a:close/>
               </a:path>
@@ -3367,8 +3397,8 @@
         </p:nvSpPr>
         <p:spPr>
           <a:xfrm>
-            <a:off x="1022535" y="4491420"/>
-            <a:ext cx="1282044" cy="1190921"/>
+            <a:off x="871706" y="4578503"/>
+            <a:ext cx="1131215" cy="1103469"/>
           </a:xfrm>
           <a:custGeom>
             <a:avLst/>
@@ -3377,282 +3407,252 @@
             <a:cxnLst/>
             <a:rect l="l" t="t" r="r" b="b"/>
             <a:pathLst>
-              <a:path w="1282044" h="1190921">
+              <a:path w="1131215" h="1103469">
                 <a:moveTo>
-                  <a:pt x="1282044" y="740210"/>
+                  <a:pt x="1131215" y="653127"/>
                 </a:moveTo>
                 <a:lnTo>
                   <a:pt x="0" y="0"/>
                 </a:lnTo>
                 <a:lnTo>
-                  <a:pt x="0" y="400584"/>
-                </a:lnTo>
-                <a:lnTo>
-                  <a:pt x="15828" y="461417"/>
-                </a:lnTo>
-                <a:lnTo>
-                  <a:pt x="31655" y="487246"/>
-                </a:lnTo>
-                <a:lnTo>
-                  <a:pt x="47483" y="505541"/>
-                </a:lnTo>
-                <a:lnTo>
-                  <a:pt x="63311" y="518874"/>
-                </a:lnTo>
-                <a:lnTo>
-                  <a:pt x="79138" y="528012"/>
-                </a:lnTo>
-                <a:lnTo>
-                  <a:pt x="94966" y="532956"/>
-                </a:lnTo>
-                <a:lnTo>
-                  <a:pt x="110794" y="532938"/>
-                </a:lnTo>
-                <a:lnTo>
-                  <a:pt x="126621" y="525386"/>
-                </a:lnTo>
-                <a:lnTo>
-                  <a:pt x="142449" y="482830"/>
-                </a:lnTo>
-                <a:lnTo>
-                  <a:pt x="142449" y="482830"/>
-                </a:lnTo>
-                <a:lnTo>
-                  <a:pt x="158277" y="543663"/>
-                </a:lnTo>
-                <a:lnTo>
-                  <a:pt x="174105" y="569492"/>
-                </a:lnTo>
-                <a:lnTo>
-                  <a:pt x="189932" y="587787"/>
-                </a:lnTo>
-                <a:lnTo>
-                  <a:pt x="205760" y="601120"/>
-                </a:lnTo>
-                <a:lnTo>
-                  <a:pt x="221588" y="610258"/>
-                </a:lnTo>
-                <a:lnTo>
-                  <a:pt x="237415" y="615202"/>
-                </a:lnTo>
-                <a:lnTo>
-                  <a:pt x="253243" y="615184"/>
-                </a:lnTo>
-                <a:lnTo>
-                  <a:pt x="269071" y="607631"/>
-                </a:lnTo>
-                <a:lnTo>
-                  <a:pt x="284899" y="565075"/>
-                </a:lnTo>
-                <a:lnTo>
-                  <a:pt x="284899" y="565075"/>
-                </a:lnTo>
-                <a:lnTo>
-                  <a:pt x="300726" y="625908"/>
-                </a:lnTo>
-                <a:lnTo>
-                  <a:pt x="316554" y="651737"/>
-                </a:lnTo>
-                <a:lnTo>
-                  <a:pt x="332382" y="670032"/>
-                </a:lnTo>
-                <a:lnTo>
-                  <a:pt x="348209" y="683365"/>
-                </a:lnTo>
-                <a:lnTo>
-                  <a:pt x="364037" y="692503"/>
-                </a:lnTo>
-                <a:lnTo>
-                  <a:pt x="379865" y="697447"/>
-                </a:lnTo>
-                <a:lnTo>
-                  <a:pt x="395692" y="697429"/>
-                </a:lnTo>
-                <a:lnTo>
-                  <a:pt x="411520" y="689877"/>
-                </a:lnTo>
-                <a:lnTo>
-                  <a:pt x="427348" y="647321"/>
-                </a:lnTo>
-                <a:lnTo>
-                  <a:pt x="427348" y="647321"/>
-                </a:lnTo>
-                <a:lnTo>
-                  <a:pt x="443176" y="708154"/>
-                </a:lnTo>
-                <a:lnTo>
-                  <a:pt x="459003" y="733983"/>
-                </a:lnTo>
-                <a:lnTo>
-                  <a:pt x="474831" y="752278"/>
-                </a:lnTo>
-                <a:lnTo>
-                  <a:pt x="490659" y="765611"/>
-                </a:lnTo>
-                <a:lnTo>
-                  <a:pt x="506486" y="774749"/>
-                </a:lnTo>
-                <a:lnTo>
-                  <a:pt x="522314" y="779693"/>
-                </a:lnTo>
-                <a:lnTo>
-                  <a:pt x="538142" y="779675"/>
-                </a:lnTo>
-                <a:lnTo>
-                  <a:pt x="553969" y="772122"/>
-                </a:lnTo>
-                <a:lnTo>
-                  <a:pt x="569797" y="729566"/>
-                </a:lnTo>
-                <a:lnTo>
-                  <a:pt x="569797" y="729566"/>
-                </a:lnTo>
-                <a:lnTo>
-                  <a:pt x="585625" y="790399"/>
-                </a:lnTo>
-                <a:lnTo>
-                  <a:pt x="601453" y="816229"/>
-                </a:lnTo>
-                <a:lnTo>
-                  <a:pt x="617280" y="834523"/>
-                </a:lnTo>
-                <a:lnTo>
-                  <a:pt x="633108" y="847856"/>
-                </a:lnTo>
-                <a:lnTo>
-                  <a:pt x="648936" y="856995"/>
-                </a:lnTo>
-                <a:lnTo>
-                  <a:pt x="664763" y="861939"/>
-                </a:lnTo>
-                <a:lnTo>
-                  <a:pt x="680591" y="861921"/>
-                </a:lnTo>
-                <a:lnTo>
-                  <a:pt x="696419" y="854368"/>
-                </a:lnTo>
-                <a:lnTo>
-                  <a:pt x="712246" y="811812"/>
-                </a:lnTo>
-                <a:lnTo>
-                  <a:pt x="712246" y="811812"/>
-                </a:lnTo>
-                <a:lnTo>
-                  <a:pt x="728074" y="872645"/>
-                </a:lnTo>
-                <a:lnTo>
-                  <a:pt x="743902" y="898474"/>
-                </a:lnTo>
-                <a:lnTo>
-                  <a:pt x="759730" y="916769"/>
-                </a:lnTo>
-                <a:lnTo>
-                  <a:pt x="775557" y="930102"/>
-                </a:lnTo>
-                <a:lnTo>
-                  <a:pt x="791385" y="939240"/>
-                </a:lnTo>
-                <a:lnTo>
-                  <a:pt x="807213" y="944184"/>
-                </a:lnTo>
-                <a:lnTo>
-                  <a:pt x="823040" y="944166"/>
-                </a:lnTo>
-                <a:lnTo>
-                  <a:pt x="838868" y="936614"/>
-                </a:lnTo>
-                <a:lnTo>
-                  <a:pt x="854696" y="894057"/>
-                </a:lnTo>
-                <a:lnTo>
-                  <a:pt x="854696" y="894057"/>
-                </a:lnTo>
-                <a:lnTo>
-                  <a:pt x="870523" y="954890"/>
-                </a:lnTo>
-                <a:lnTo>
-                  <a:pt x="886351" y="980720"/>
-                </a:lnTo>
-                <a:lnTo>
-                  <a:pt x="902179" y="999014"/>
-                </a:lnTo>
-                <a:lnTo>
-                  <a:pt x="918007" y="1012347"/>
-                </a:lnTo>
-                <a:lnTo>
-                  <a:pt x="933834" y="1021486"/>
-                </a:lnTo>
-                <a:lnTo>
-                  <a:pt x="949662" y="1026430"/>
-                </a:lnTo>
-                <a:lnTo>
-                  <a:pt x="965490" y="1026412"/>
-                </a:lnTo>
-                <a:lnTo>
-                  <a:pt x="981317" y="1018859"/>
-                </a:lnTo>
-                <a:lnTo>
-                  <a:pt x="997145" y="976303"/>
-                </a:lnTo>
-                <a:lnTo>
-                  <a:pt x="997145" y="976303"/>
-                </a:lnTo>
-                <a:lnTo>
-                  <a:pt x="1012973" y="1037136"/>
-                </a:lnTo>
-                <a:lnTo>
-                  <a:pt x="1028800" y="1062965"/>
-                </a:lnTo>
-                <a:lnTo>
-                  <a:pt x="1044628" y="1081260"/>
-                </a:lnTo>
-                <a:lnTo>
-                  <a:pt x="1060456" y="1094593"/>
-                </a:lnTo>
-                <a:lnTo>
-                  <a:pt x="1076284" y="1103731"/>
-                </a:lnTo>
-                <a:lnTo>
-                  <a:pt x="1092111" y="1108675"/>
-                </a:lnTo>
-                <a:lnTo>
-                  <a:pt x="1107939" y="1108657"/>
-                </a:lnTo>
-                <a:lnTo>
-                  <a:pt x="1123767" y="1101105"/>
-                </a:lnTo>
-                <a:lnTo>
-                  <a:pt x="1139594" y="1058549"/>
-                </a:lnTo>
-                <a:lnTo>
-                  <a:pt x="1139594" y="1058549"/>
-                </a:lnTo>
-                <a:lnTo>
-                  <a:pt x="1155422" y="1119382"/>
-                </a:lnTo>
-                <a:lnTo>
-                  <a:pt x="1171250" y="1145211"/>
-                </a:lnTo>
-                <a:lnTo>
-                  <a:pt x="1187077" y="1163506"/>
-                </a:lnTo>
-                <a:lnTo>
-                  <a:pt x="1202905" y="1176838"/>
-                </a:lnTo>
-                <a:lnTo>
-                  <a:pt x="1218733" y="1185977"/>
-                </a:lnTo>
-                <a:lnTo>
-                  <a:pt x="1234561" y="1190921"/>
-                </a:lnTo>
-                <a:lnTo>
-                  <a:pt x="1250388" y="1190903"/>
-                </a:lnTo>
-                <a:lnTo>
-                  <a:pt x="1266216" y="1183350"/>
-                </a:lnTo>
-                <a:lnTo>
-                  <a:pt x="1282044" y="1140794"/>
+                  <a:pt x="0" y="400585"/>
+                </a:lnTo>
+                <a:lnTo>
+                  <a:pt x="15712" y="460970"/>
+                </a:lnTo>
+                <a:lnTo>
+                  <a:pt x="31423" y="486610"/>
+                </a:lnTo>
+                <a:lnTo>
+                  <a:pt x="47134" y="504770"/>
+                </a:lnTo>
+                <a:lnTo>
+                  <a:pt x="62845" y="518005"/>
+                </a:lnTo>
+                <a:lnTo>
+                  <a:pt x="78557" y="527076"/>
+                </a:lnTo>
+                <a:lnTo>
+                  <a:pt x="94268" y="531984"/>
+                </a:lnTo>
+                <a:lnTo>
+                  <a:pt x="109979" y="531966"/>
+                </a:lnTo>
+                <a:lnTo>
+                  <a:pt x="125691" y="524469"/>
+                </a:lnTo>
+                <a:lnTo>
+                  <a:pt x="141402" y="482225"/>
+                </a:lnTo>
+                <a:lnTo>
+                  <a:pt x="141402" y="482225"/>
+                </a:lnTo>
+                <a:lnTo>
+                  <a:pt x="157113" y="542611"/>
+                </a:lnTo>
+                <a:lnTo>
+                  <a:pt x="172825" y="568250"/>
+                </a:lnTo>
+                <a:lnTo>
+                  <a:pt x="188536" y="586411"/>
+                </a:lnTo>
+                <a:lnTo>
+                  <a:pt x="204247" y="599646"/>
+                </a:lnTo>
+                <a:lnTo>
+                  <a:pt x="219959" y="608717"/>
+                </a:lnTo>
+                <a:lnTo>
+                  <a:pt x="235670" y="613624"/>
+                </a:lnTo>
+                <a:lnTo>
+                  <a:pt x="251381" y="613606"/>
+                </a:lnTo>
+                <a:lnTo>
+                  <a:pt x="267093" y="606109"/>
+                </a:lnTo>
+                <a:lnTo>
+                  <a:pt x="282804" y="563866"/>
+                </a:lnTo>
+                <a:lnTo>
+                  <a:pt x="282804" y="563866"/>
+                </a:lnTo>
+                <a:lnTo>
+                  <a:pt x="298515" y="624252"/>
+                </a:lnTo>
+                <a:lnTo>
+                  <a:pt x="314227" y="649891"/>
+                </a:lnTo>
+                <a:lnTo>
+                  <a:pt x="329938" y="668052"/>
+                </a:lnTo>
+                <a:lnTo>
+                  <a:pt x="345649" y="681286"/>
+                </a:lnTo>
+                <a:lnTo>
+                  <a:pt x="361361" y="690358"/>
+                </a:lnTo>
+                <a:lnTo>
+                  <a:pt x="377072" y="695265"/>
+                </a:lnTo>
+                <a:lnTo>
+                  <a:pt x="392783" y="695247"/>
+                </a:lnTo>
+                <a:lnTo>
+                  <a:pt x="408495" y="687750"/>
+                </a:lnTo>
+                <a:lnTo>
+                  <a:pt x="424206" y="645507"/>
+                </a:lnTo>
+                <a:lnTo>
+                  <a:pt x="424206" y="645507"/>
+                </a:lnTo>
+                <a:lnTo>
+                  <a:pt x="439917" y="705893"/>
+                </a:lnTo>
+                <a:lnTo>
+                  <a:pt x="455629" y="731532"/>
+                </a:lnTo>
+                <a:lnTo>
+                  <a:pt x="471340" y="749692"/>
+                </a:lnTo>
+                <a:lnTo>
+                  <a:pt x="487051" y="762927"/>
+                </a:lnTo>
+                <a:lnTo>
+                  <a:pt x="502762" y="771998"/>
+                </a:lnTo>
+                <a:lnTo>
+                  <a:pt x="518474" y="776906"/>
+                </a:lnTo>
+                <a:lnTo>
+                  <a:pt x="534185" y="776888"/>
+                </a:lnTo>
+                <a:lnTo>
+                  <a:pt x="549896" y="769391"/>
+                </a:lnTo>
+                <a:lnTo>
+                  <a:pt x="565608" y="727148"/>
+                </a:lnTo>
+                <a:lnTo>
+                  <a:pt x="565608" y="727148"/>
+                </a:lnTo>
+                <a:lnTo>
+                  <a:pt x="581319" y="787534"/>
+                </a:lnTo>
+                <a:lnTo>
+                  <a:pt x="597030" y="813173"/>
+                </a:lnTo>
+                <a:lnTo>
+                  <a:pt x="612742" y="831333"/>
+                </a:lnTo>
+                <a:lnTo>
+                  <a:pt x="628453" y="844568"/>
+                </a:lnTo>
+                <a:lnTo>
+                  <a:pt x="644164" y="853639"/>
+                </a:lnTo>
+                <a:lnTo>
+                  <a:pt x="659876" y="858547"/>
+                </a:lnTo>
+                <a:lnTo>
+                  <a:pt x="675587" y="858529"/>
+                </a:lnTo>
+                <a:lnTo>
+                  <a:pt x="691298" y="851032"/>
+                </a:lnTo>
+                <a:lnTo>
+                  <a:pt x="707010" y="808789"/>
+                </a:lnTo>
+                <a:lnTo>
+                  <a:pt x="707010" y="808789"/>
+                </a:lnTo>
+                <a:lnTo>
+                  <a:pt x="722721" y="869174"/>
+                </a:lnTo>
+                <a:lnTo>
+                  <a:pt x="738432" y="894814"/>
+                </a:lnTo>
+                <a:lnTo>
+                  <a:pt x="754144" y="912974"/>
+                </a:lnTo>
+                <a:lnTo>
+                  <a:pt x="769855" y="926209"/>
+                </a:lnTo>
+                <a:lnTo>
+                  <a:pt x="785566" y="935280"/>
+                </a:lnTo>
+                <a:lnTo>
+                  <a:pt x="801278" y="940188"/>
+                </a:lnTo>
+                <a:lnTo>
+                  <a:pt x="816989" y="940170"/>
+                </a:lnTo>
+                <a:lnTo>
+                  <a:pt x="832700" y="932673"/>
+                </a:lnTo>
+                <a:lnTo>
+                  <a:pt x="848412" y="890429"/>
+                </a:lnTo>
+                <a:lnTo>
+                  <a:pt x="848412" y="890429"/>
+                </a:lnTo>
+                <a:lnTo>
+                  <a:pt x="864123" y="950815"/>
+                </a:lnTo>
+                <a:lnTo>
+                  <a:pt x="879834" y="976455"/>
+                </a:lnTo>
+                <a:lnTo>
+                  <a:pt x="895546" y="994615"/>
+                </a:lnTo>
+                <a:lnTo>
+                  <a:pt x="911257" y="1007850"/>
+                </a:lnTo>
+                <a:lnTo>
+                  <a:pt x="926968" y="1016921"/>
+                </a:lnTo>
+                <a:lnTo>
+                  <a:pt x="942679" y="1021828"/>
+                </a:lnTo>
+                <a:lnTo>
+                  <a:pt x="958391" y="1021811"/>
+                </a:lnTo>
+                <a:lnTo>
+                  <a:pt x="974102" y="1014314"/>
+                </a:lnTo>
+                <a:lnTo>
+                  <a:pt x="989813" y="972070"/>
+                </a:lnTo>
+                <a:lnTo>
+                  <a:pt x="989813" y="972070"/>
+                </a:lnTo>
+                <a:lnTo>
+                  <a:pt x="1005525" y="1032456"/>
+                </a:lnTo>
+                <a:lnTo>
+                  <a:pt x="1021236" y="1058095"/>
+                </a:lnTo>
+                <a:lnTo>
+                  <a:pt x="1036947" y="1076256"/>
+                </a:lnTo>
+                <a:lnTo>
+                  <a:pt x="1052659" y="1089490"/>
+                </a:lnTo>
+                <a:lnTo>
+                  <a:pt x="1068370" y="1098562"/>
+                </a:lnTo>
+                <a:lnTo>
+                  <a:pt x="1084081" y="1103469"/>
+                </a:lnTo>
+                <a:lnTo>
+                  <a:pt x="1099793" y="1103451"/>
+                </a:lnTo>
+                <a:lnTo>
+                  <a:pt x="1115504" y="1095954"/>
+                </a:lnTo>
+                <a:lnTo>
+                  <a:pt x="1131215" y="1053711"/>
                 </a:lnTo>
                 <a:close/>
               </a:path>
@@ -3698,8 +3698,8 @@
         </p:nvCxnSpPr>
         <p:spPr>
           <a:xfrm>
-            <a:off x="3337215" y="4865879"/>
-            <a:ext cx="337710" cy="0"/>
+            <a:off x="3186387" y="4778795"/>
+            <a:ext cx="488538" cy="0"/>
           </a:xfrm>
           <a:prstGeom prst="line">
             <a:avLst/>
@@ -3734,7 +3734,7 @@
         </p:nvSpPr>
         <p:spPr>
           <a:xfrm>
-            <a:off x="3744592" y="4701727"/>
+            <a:off x="3744592" y="4614643"/>
             <a:ext cx="2960840" cy="328305"/>
           </a:xfrm>
           <a:prstGeom prst="rect">
@@ -3769,8 +3769,8 @@
         </p:nvSpPr>
         <p:spPr>
           <a:xfrm>
-            <a:off x="2304579" y="4378211"/>
-            <a:ext cx="980386" cy="853419"/>
+            <a:off x="2002921" y="4291128"/>
+            <a:ext cx="1131215" cy="940502"/>
           </a:xfrm>
           <a:custGeom>
             <a:avLst/>
@@ -3779,18 +3779,18 @@
             <a:cxnLst/>
             <a:rect l="l" t="t" r="r" b="b"/>
             <a:pathLst>
-              <a:path w="980386" h="853419">
+              <a:path w="1131215" h="940502">
                 <a:moveTo>
-                  <a:pt x="980386" y="287376"/>
+                  <a:pt x="1131215" y="287375"/>
                 </a:moveTo>
                 <a:lnTo>
-                  <a:pt x="980386" y="0"/>
-                </a:lnTo>
-                <a:lnTo>
-                  <a:pt x="0" y="566043"/>
-                </a:lnTo>
-                <a:lnTo>
-                  <a:pt x="0" y="853419"/>
+                  <a:pt x="1131215" y="0"/>
+                </a:lnTo>
+                <a:lnTo>
+                  <a:pt x="0" y="653126"/>
+                </a:lnTo>
+                <a:lnTo>
+                  <a:pt x="0" y="940502"/>
                 </a:lnTo>
                 <a:close/>
               </a:path>
@@ -3836,8 +3836,8 @@
         </p:nvSpPr>
         <p:spPr>
           <a:xfrm>
-            <a:off x="1022535" y="4204044"/>
-            <a:ext cx="1282044" cy="1027586"/>
+            <a:off x="871706" y="4291128"/>
+            <a:ext cx="1131215" cy="940502"/>
           </a:xfrm>
           <a:custGeom>
             <a:avLst/>
@@ -3846,18 +3846,18 @@
             <a:cxnLst/>
             <a:rect l="l" t="t" r="r" b="b"/>
             <a:pathLst>
-              <a:path w="1282044" h="1027586">
+              <a:path w="1131215" h="940502">
                 <a:moveTo>
-                  <a:pt x="1282044" y="1027586"/>
+                  <a:pt x="1131215" y="940502"/>
                 </a:moveTo>
                 <a:lnTo>
-                  <a:pt x="1282044" y="740210"/>
+                  <a:pt x="1131215" y="653126"/>
                 </a:lnTo>
                 <a:lnTo>
                   <a:pt x="0" y="0"/>
                 </a:lnTo>
                 <a:lnTo>
-                  <a:pt x="0" y="287376"/>
+                  <a:pt x="0" y="287375"/>
                 </a:lnTo>
                 <a:close/>
               </a:path>
@@ -3903,8 +3903,8 @@
         </p:nvCxnSpPr>
         <p:spPr>
           <a:xfrm>
-            <a:off x="3337215" y="4521899"/>
-            <a:ext cx="337710" cy="0"/>
+            <a:off x="3186387" y="4434815"/>
+            <a:ext cx="488538" cy="0"/>
           </a:xfrm>
           <a:prstGeom prst="line">
             <a:avLst/>
@@ -3939,7 +3939,7 @@
         </p:nvSpPr>
         <p:spPr>
           <a:xfrm>
-            <a:off x="3744592" y="4357747"/>
+            <a:off x="3744592" y="4270663"/>
             <a:ext cx="2960840" cy="328305"/>
           </a:xfrm>
           <a:prstGeom prst="rect">
@@ -3974,8 +3974,8 @@
         </p:nvSpPr>
         <p:spPr>
           <a:xfrm>
-            <a:off x="2304579" y="4090836"/>
-            <a:ext cx="980386" cy="853418"/>
+            <a:off x="2002921" y="4003752"/>
+            <a:ext cx="1131215" cy="940502"/>
           </a:xfrm>
           <a:custGeom>
             <a:avLst/>
@@ -3984,18 +3984,18 @@
             <a:cxnLst/>
             <a:rect l="l" t="t" r="r" b="b"/>
             <a:pathLst>
-              <a:path w="980386" h="853418">
+              <a:path w="1131215" h="940502">
                 <a:moveTo>
-                  <a:pt x="980386" y="287375"/>
+                  <a:pt x="1131215" y="287376"/>
                 </a:moveTo>
                 <a:lnTo>
-                  <a:pt x="980386" y="0"/>
-                </a:lnTo>
-                <a:lnTo>
-                  <a:pt x="0" y="566043"/>
-                </a:lnTo>
-                <a:lnTo>
-                  <a:pt x="0" y="853418"/>
+                  <a:pt x="1131215" y="0"/>
+                </a:lnTo>
+                <a:lnTo>
+                  <a:pt x="0" y="653127"/>
+                </a:lnTo>
+                <a:lnTo>
+                  <a:pt x="0" y="940502"/>
                 </a:lnTo>
                 <a:close/>
               </a:path>
@@ -4041,8 +4041,8 @@
         </p:nvSpPr>
         <p:spPr>
           <a:xfrm>
-            <a:off x="1022535" y="3916668"/>
-            <a:ext cx="1282044" cy="1027586"/>
+            <a:off x="871706" y="4003752"/>
+            <a:ext cx="1131215" cy="940502"/>
           </a:xfrm>
           <a:custGeom>
             <a:avLst/>
@@ -4051,12 +4051,12 @@
             <a:cxnLst/>
             <a:rect l="l" t="t" r="r" b="b"/>
             <a:pathLst>
-              <a:path w="1282044" h="1027586">
+              <a:path w="1131215" h="940502">
                 <a:moveTo>
-                  <a:pt x="1282044" y="1027586"/>
+                  <a:pt x="1131215" y="940502"/>
                 </a:moveTo>
                 <a:lnTo>
-                  <a:pt x="1282044" y="740211"/>
+                  <a:pt x="1131215" y="653127"/>
                 </a:lnTo>
                 <a:lnTo>
                   <a:pt x="0" y="0"/>
@@ -4108,8 +4108,8 @@
         </p:nvCxnSpPr>
         <p:spPr>
           <a:xfrm>
-            <a:off x="3337215" y="4234523"/>
-            <a:ext cx="337710" cy="0"/>
+            <a:off x="3186387" y="4147440"/>
+            <a:ext cx="488538" cy="0"/>
           </a:xfrm>
           <a:prstGeom prst="line">
             <a:avLst/>
@@ -4144,7 +4144,7 @@
         </p:nvSpPr>
         <p:spPr>
           <a:xfrm>
-            <a:off x="3744592" y="4070371"/>
+            <a:off x="3744592" y="3983287"/>
             <a:ext cx="2960840" cy="328305"/>
           </a:xfrm>
           <a:prstGeom prst="rect">
@@ -4179,8 +4179,8 @@
         </p:nvSpPr>
         <p:spPr>
           <a:xfrm>
-            <a:off x="2304579" y="3847002"/>
-            <a:ext cx="980386" cy="809877"/>
+            <a:off x="2002921" y="3759918"/>
+            <a:ext cx="1131215" cy="896961"/>
           </a:xfrm>
           <a:custGeom>
             <a:avLst/>
@@ -4189,18 +4189,18 @@
             <a:cxnLst/>
             <a:rect l="l" t="t" r="r" b="b"/>
             <a:pathLst>
-              <a:path w="980386" h="809877">
+              <a:path w="1131215" h="896961">
                 <a:moveTo>
-                  <a:pt x="980386" y="243834"/>
+                  <a:pt x="1131215" y="243834"/>
                 </a:moveTo>
                 <a:lnTo>
-                  <a:pt x="980386" y="0"/>
-                </a:lnTo>
-                <a:lnTo>
-                  <a:pt x="0" y="566043"/>
-                </a:lnTo>
-                <a:lnTo>
-                  <a:pt x="0" y="809877"/>
+                  <a:pt x="1131215" y="0"/>
+                </a:lnTo>
+                <a:lnTo>
+                  <a:pt x="0" y="653127"/>
+                </a:lnTo>
+                <a:lnTo>
+                  <a:pt x="0" y="896961"/>
                 </a:lnTo>
                 <a:close/>
               </a:path>
@@ -4246,8 +4246,8 @@
         </p:nvSpPr>
         <p:spPr>
           <a:xfrm>
-            <a:off x="1022535" y="3672835"/>
-            <a:ext cx="1282044" cy="984044"/>
+            <a:off x="871706" y="3759918"/>
+            <a:ext cx="1131215" cy="896961"/>
           </a:xfrm>
           <a:custGeom>
             <a:avLst/>
@@ -4256,18 +4256,18 @@
             <a:cxnLst/>
             <a:rect l="l" t="t" r="r" b="b"/>
             <a:pathLst>
-              <a:path w="1282044" h="984044">
+              <a:path w="1131215" h="896961">
                 <a:moveTo>
-                  <a:pt x="1282044" y="984044"/>
+                  <a:pt x="1131215" y="896961"/>
                 </a:moveTo>
                 <a:lnTo>
-                  <a:pt x="1282044" y="740210"/>
+                  <a:pt x="1131215" y="653127"/>
                 </a:lnTo>
                 <a:lnTo>
                   <a:pt x="0" y="0"/>
                 </a:lnTo>
                 <a:lnTo>
-                  <a:pt x="0" y="243833"/>
+                  <a:pt x="0" y="243834"/>
                 </a:lnTo>
                 <a:close/>
               </a:path>
@@ -4313,8 +4313,8 @@
         </p:nvCxnSpPr>
         <p:spPr>
           <a:xfrm>
-            <a:off x="3337215" y="3968919"/>
-            <a:ext cx="337710" cy="0"/>
+            <a:off x="3186387" y="3881835"/>
+            <a:ext cx="488538" cy="0"/>
           </a:xfrm>
           <a:prstGeom prst="line">
             <a:avLst/>
@@ -4349,7 +4349,7 @@
         </p:nvSpPr>
         <p:spPr>
           <a:xfrm>
-            <a:off x="3744592" y="3804766"/>
+            <a:off x="3744592" y="3717683"/>
             <a:ext cx="2960840" cy="328305"/>
           </a:xfrm>
           <a:prstGeom prst="rect">
@@ -4384,8 +4384,8 @@
         </p:nvSpPr>
         <p:spPr>
           <a:xfrm>
-            <a:off x="2304579" y="3533501"/>
-            <a:ext cx="980386" cy="879544"/>
+            <a:off x="2002921" y="3446417"/>
+            <a:ext cx="1131215" cy="966628"/>
           </a:xfrm>
           <a:custGeom>
             <a:avLst/>
@@ -4394,18 +4394,18 @@
             <a:cxnLst/>
             <a:rect l="l" t="t" r="r" b="b"/>
             <a:pathLst>
-              <a:path w="980386" h="879544">
+              <a:path w="1131215" h="966628">
                 <a:moveTo>
-                  <a:pt x="980386" y="313501"/>
+                  <a:pt x="1131215" y="313501"/>
                 </a:moveTo>
                 <a:lnTo>
-                  <a:pt x="980386" y="0"/>
-                </a:lnTo>
-                <a:lnTo>
-                  <a:pt x="0" y="566043"/>
-                </a:lnTo>
-                <a:lnTo>
-                  <a:pt x="0" y="879544"/>
+                  <a:pt x="1131215" y="0"/>
+                </a:lnTo>
+                <a:lnTo>
+                  <a:pt x="0" y="653127"/>
+                </a:lnTo>
+                <a:lnTo>
+                  <a:pt x="0" y="966628"/>
                 </a:lnTo>
                 <a:close/>
               </a:path>
@@ -4451,8 +4451,8 @@
         </p:nvSpPr>
         <p:spPr>
           <a:xfrm>
-            <a:off x="1022535" y="3359334"/>
-            <a:ext cx="1282044" cy="1053711"/>
+            <a:off x="871706" y="3446417"/>
+            <a:ext cx="1131215" cy="966628"/>
           </a:xfrm>
           <a:custGeom>
             <a:avLst/>
@@ -4461,12 +4461,12 @@
             <a:cxnLst/>
             <a:rect l="l" t="t" r="r" b="b"/>
             <a:pathLst>
-              <a:path w="1282044" h="1053711">
+              <a:path w="1131215" h="966628">
                 <a:moveTo>
-                  <a:pt x="1282044" y="1053711"/>
+                  <a:pt x="1131215" y="966628"/>
                 </a:moveTo>
                 <a:lnTo>
-                  <a:pt x="1282044" y="740210"/>
+                  <a:pt x="1131215" y="653127"/>
                 </a:lnTo>
                 <a:lnTo>
                   <a:pt x="0" y="0"/>
@@ -4518,8 +4518,8 @@
         </p:nvCxnSpPr>
         <p:spPr>
           <a:xfrm>
-            <a:off x="3337215" y="3690251"/>
-            <a:ext cx="337710" cy="0"/>
+            <a:off x="3186387" y="3603168"/>
+            <a:ext cx="488538" cy="0"/>
           </a:xfrm>
           <a:prstGeom prst="line">
             <a:avLst/>
@@ -4554,7 +4554,7 @@
         </p:nvSpPr>
         <p:spPr>
           <a:xfrm>
-            <a:off x="3744592" y="3526099"/>
+            <a:off x="3744592" y="3439015"/>
             <a:ext cx="2960840" cy="328305"/>
           </a:xfrm>
           <a:prstGeom prst="rect">
@@ -4607,8 +4607,8 @@
         </p:nvSpPr>
         <p:spPr>
           <a:xfrm>
-            <a:off x="2304579" y="3246125"/>
-            <a:ext cx="980386" cy="853419"/>
+            <a:off x="2002921" y="3159042"/>
+            <a:ext cx="1131215" cy="940502"/>
           </a:xfrm>
           <a:custGeom>
             <a:avLst/>
@@ -4617,18 +4617,18 @@
             <a:cxnLst/>
             <a:rect l="l" t="t" r="r" b="b"/>
             <a:pathLst>
-              <a:path w="980386" h="853419">
+              <a:path w="1131215" h="940502">
                 <a:moveTo>
-                  <a:pt x="980386" y="287376"/>
+                  <a:pt x="1131215" y="287375"/>
                 </a:moveTo>
                 <a:lnTo>
-                  <a:pt x="980386" y="0"/>
-                </a:lnTo>
-                <a:lnTo>
-                  <a:pt x="0" y="566043"/>
-                </a:lnTo>
-                <a:lnTo>
-                  <a:pt x="0" y="853419"/>
+                  <a:pt x="1131215" y="0"/>
+                </a:lnTo>
+                <a:lnTo>
+                  <a:pt x="0" y="653126"/>
+                </a:lnTo>
+                <a:lnTo>
+                  <a:pt x="0" y="940502"/>
                 </a:lnTo>
                 <a:close/>
               </a:path>
@@ -4674,8 +4674,8 @@
         </p:nvSpPr>
         <p:spPr>
           <a:xfrm>
-            <a:off x="1022535" y="3071958"/>
-            <a:ext cx="1282044" cy="1027586"/>
+            <a:off x="871706" y="3159042"/>
+            <a:ext cx="1131215" cy="940502"/>
           </a:xfrm>
           <a:custGeom>
             <a:avLst/>
@@ -4684,18 +4684,18 @@
             <a:cxnLst/>
             <a:rect l="l" t="t" r="r" b="b"/>
             <a:pathLst>
-              <a:path w="1282044" h="1027586">
+              <a:path w="1131215" h="940502">
                 <a:moveTo>
-                  <a:pt x="1282044" y="1027586"/>
+                  <a:pt x="1131215" y="940502"/>
                 </a:moveTo>
                 <a:lnTo>
-                  <a:pt x="1282044" y="740210"/>
+                  <a:pt x="1131215" y="653126"/>
                 </a:lnTo>
                 <a:lnTo>
                   <a:pt x="0" y="0"/>
                 </a:lnTo>
                 <a:lnTo>
-                  <a:pt x="0" y="287376"/>
+                  <a:pt x="0" y="287375"/>
                 </a:lnTo>
                 <a:close/>
               </a:path>
@@ -4741,8 +4741,8 @@
         </p:nvCxnSpPr>
         <p:spPr>
           <a:xfrm>
-            <a:off x="3337215" y="3389813"/>
-            <a:ext cx="337710" cy="0"/>
+            <a:off x="3186387" y="3302730"/>
+            <a:ext cx="488538" cy="0"/>
           </a:xfrm>
           <a:prstGeom prst="line">
             <a:avLst/>
@@ -4777,7 +4777,7 @@
         </p:nvSpPr>
         <p:spPr>
           <a:xfrm>
-            <a:off x="3744592" y="3225661"/>
+            <a:off x="3744592" y="3138577"/>
             <a:ext cx="2960840" cy="328305"/>
           </a:xfrm>
           <a:prstGeom prst="rect">
@@ -4812,8 +4812,8 @@
         </p:nvSpPr>
         <p:spPr>
           <a:xfrm>
-            <a:off x="2304579" y="3019708"/>
-            <a:ext cx="980386" cy="792460"/>
+            <a:off x="2002921" y="2932625"/>
+            <a:ext cx="1131215" cy="879543"/>
           </a:xfrm>
           <a:custGeom>
             <a:avLst/>
@@ -4822,18 +4822,18 @@
             <a:cxnLst/>
             <a:rect l="l" t="t" r="r" b="b"/>
             <a:pathLst>
-              <a:path w="980386" h="792460">
+              <a:path w="1131215" h="879543">
                 <a:moveTo>
-                  <a:pt x="980386" y="226417"/>
+                  <a:pt x="1131215" y="226417"/>
                 </a:moveTo>
                 <a:lnTo>
-                  <a:pt x="980386" y="0"/>
-                </a:lnTo>
-                <a:lnTo>
-                  <a:pt x="0" y="566043"/>
-                </a:lnTo>
-                <a:lnTo>
-                  <a:pt x="0" y="792460"/>
+                  <a:pt x="1131215" y="0"/>
+                </a:lnTo>
+                <a:lnTo>
+                  <a:pt x="0" y="653126"/>
+                </a:lnTo>
+                <a:lnTo>
+                  <a:pt x="0" y="879543"/>
                 </a:lnTo>
                 <a:close/>
               </a:path>
@@ -4879,8 +4879,8 @@
         </p:nvSpPr>
         <p:spPr>
           <a:xfrm>
-            <a:off x="1022535" y="2845541"/>
-            <a:ext cx="1282044" cy="966627"/>
+            <a:off x="871706" y="2932625"/>
+            <a:ext cx="1131215" cy="879543"/>
           </a:xfrm>
           <a:custGeom>
             <a:avLst/>
@@ -4889,12 +4889,12 @@
             <a:cxnLst/>
             <a:rect l="l" t="t" r="r" b="b"/>
             <a:pathLst>
-              <a:path w="1282044" h="966627">
+              <a:path w="1131215" h="879543">
                 <a:moveTo>
-                  <a:pt x="1282044" y="966627"/>
+                  <a:pt x="1131215" y="879543"/>
                 </a:moveTo>
                 <a:lnTo>
-                  <a:pt x="1282044" y="740210"/>
+                  <a:pt x="1131215" y="653126"/>
                 </a:lnTo>
                 <a:lnTo>
                   <a:pt x="0" y="0"/>
@@ -4946,8 +4946,8 @@
         </p:nvCxnSpPr>
         <p:spPr>
           <a:xfrm>
-            <a:off x="3337215" y="3132917"/>
-            <a:ext cx="337710" cy="0"/>
+            <a:off x="3186387" y="3045833"/>
+            <a:ext cx="488538" cy="0"/>
           </a:xfrm>
           <a:prstGeom prst="line">
             <a:avLst/>
@@ -4982,7 +4982,7 @@
         </p:nvSpPr>
         <p:spPr>
           <a:xfrm>
-            <a:off x="3744592" y="2968764"/>
+            <a:off x="3744592" y="2881681"/>
             <a:ext cx="2960840" cy="328305"/>
           </a:xfrm>
           <a:prstGeom prst="rect">
@@ -5053,8 +5053,8 @@
         </p:nvSpPr>
         <p:spPr>
           <a:xfrm>
-            <a:off x="2304579" y="2758457"/>
-            <a:ext cx="980386" cy="827294"/>
+            <a:off x="2002921" y="2671374"/>
+            <a:ext cx="1131215" cy="914377"/>
           </a:xfrm>
           <a:custGeom>
             <a:avLst/>
@@ -5063,18 +5063,18 @@
             <a:cxnLst/>
             <a:rect l="l" t="t" r="r" b="b"/>
             <a:pathLst>
-              <a:path w="980386" h="827294">
+              <a:path w="1131215" h="914377">
                 <a:moveTo>
-                  <a:pt x="980386" y="261251"/>
+                  <a:pt x="1131215" y="261251"/>
                 </a:moveTo>
                 <a:lnTo>
-                  <a:pt x="980386" y="0"/>
-                </a:lnTo>
-                <a:lnTo>
-                  <a:pt x="0" y="566043"/>
-                </a:lnTo>
-                <a:lnTo>
-                  <a:pt x="0" y="827294"/>
+                  <a:pt x="1131215" y="0"/>
+                </a:lnTo>
+                <a:lnTo>
+                  <a:pt x="0" y="653126"/>
+                </a:lnTo>
+                <a:lnTo>
+                  <a:pt x="0" y="914377"/>
                 </a:lnTo>
                 <a:close/>
               </a:path>
@@ -5120,8 +5120,8 @@
         </p:nvSpPr>
         <p:spPr>
           <a:xfrm>
-            <a:off x="1022535" y="2584290"/>
-            <a:ext cx="1282044" cy="1001461"/>
+            <a:off x="871706" y="2671374"/>
+            <a:ext cx="1131215" cy="914377"/>
           </a:xfrm>
           <a:custGeom>
             <a:avLst/>
@@ -5130,12 +5130,12 @@
             <a:cxnLst/>
             <a:rect l="l" t="t" r="r" b="b"/>
             <a:pathLst>
-              <a:path w="1282044" h="1001461">
+              <a:path w="1131215" h="914377">
                 <a:moveTo>
-                  <a:pt x="1282044" y="1001461"/>
+                  <a:pt x="1131215" y="914377"/>
                 </a:moveTo>
                 <a:lnTo>
-                  <a:pt x="1282044" y="740210"/>
+                  <a:pt x="1131215" y="653126"/>
                 </a:lnTo>
                 <a:lnTo>
                   <a:pt x="0" y="0"/>
@@ -5187,8 +5187,8 @@
         </p:nvCxnSpPr>
         <p:spPr>
           <a:xfrm>
-            <a:off x="3337215" y="2889083"/>
-            <a:ext cx="337710" cy="0"/>
+            <a:off x="3186387" y="2801999"/>
+            <a:ext cx="488538" cy="0"/>
           </a:xfrm>
           <a:prstGeom prst="line">
             <a:avLst/>
@@ -5223,7 +5223,7 @@
         </p:nvSpPr>
         <p:spPr>
           <a:xfrm>
-            <a:off x="3744592" y="2724930"/>
+            <a:off x="3744592" y="2637847"/>
             <a:ext cx="2960840" cy="328305"/>
           </a:xfrm>
           <a:prstGeom prst="rect">
@@ -5258,8 +5258,8 @@
         </p:nvSpPr>
         <p:spPr>
           <a:xfrm>
-            <a:off x="2304579" y="2471082"/>
-            <a:ext cx="980386" cy="853418"/>
+            <a:off x="2002921" y="2383998"/>
+            <a:ext cx="1131215" cy="940502"/>
           </a:xfrm>
           <a:custGeom>
             <a:avLst/>
@@ -5268,18 +5268,18 @@
             <a:cxnLst/>
             <a:rect l="l" t="t" r="r" b="b"/>
             <a:pathLst>
-              <a:path w="980386" h="853418">
+              <a:path w="1131215" h="940502">
                 <a:moveTo>
-                  <a:pt x="980386" y="287375"/>
+                  <a:pt x="1131215" y="287376"/>
                 </a:moveTo>
                 <a:lnTo>
-                  <a:pt x="980386" y="0"/>
-                </a:lnTo>
-                <a:lnTo>
-                  <a:pt x="0" y="566043"/>
-                </a:lnTo>
-                <a:lnTo>
-                  <a:pt x="0" y="853418"/>
+                  <a:pt x="1131215" y="0"/>
+                </a:lnTo>
+                <a:lnTo>
+                  <a:pt x="0" y="653127"/>
+                </a:lnTo>
+                <a:lnTo>
+                  <a:pt x="0" y="940502"/>
                 </a:lnTo>
                 <a:close/>
               </a:path>
@@ -5325,8 +5325,8 @@
         </p:nvSpPr>
         <p:spPr>
           <a:xfrm>
-            <a:off x="1022535" y="2296915"/>
-            <a:ext cx="1282044" cy="1027585"/>
+            <a:off x="871706" y="2383998"/>
+            <a:ext cx="1131215" cy="940502"/>
           </a:xfrm>
           <a:custGeom>
             <a:avLst/>
@@ -5335,18 +5335,18 @@
             <a:cxnLst/>
             <a:rect l="l" t="t" r="r" b="b"/>
             <a:pathLst>
-              <a:path w="1282044" h="1027585">
+              <a:path w="1131215" h="940502">
                 <a:moveTo>
-                  <a:pt x="1282044" y="1027585"/>
+                  <a:pt x="1131215" y="940502"/>
                 </a:moveTo>
                 <a:lnTo>
-                  <a:pt x="1282044" y="740210"/>
+                  <a:pt x="1131215" y="653127"/>
                 </a:lnTo>
                 <a:lnTo>
                   <a:pt x="0" y="0"/>
                 </a:lnTo>
                 <a:lnTo>
-                  <a:pt x="0" y="287375"/>
+                  <a:pt x="0" y="287376"/>
                 </a:lnTo>
                 <a:close/>
               </a:path>
@@ -5392,8 +5392,8 @@
         </p:nvCxnSpPr>
         <p:spPr>
           <a:xfrm>
-            <a:off x="3337215" y="2614770"/>
-            <a:ext cx="337710" cy="0"/>
+            <a:off x="3186387" y="2527686"/>
+            <a:ext cx="488538" cy="0"/>
           </a:xfrm>
           <a:prstGeom prst="line">
             <a:avLst/>
@@ -5428,7 +5428,7 @@
         </p:nvSpPr>
         <p:spPr>
           <a:xfrm>
-            <a:off x="3744592" y="2450617"/>
+            <a:off x="3744592" y="2363534"/>
             <a:ext cx="2960840" cy="328305"/>
           </a:xfrm>
           <a:prstGeom prst="rect">
@@ -5463,8 +5463,8 @@
         </p:nvSpPr>
         <p:spPr>
           <a:xfrm>
-            <a:off x="2304579" y="2122748"/>
-            <a:ext cx="980386" cy="914377"/>
+            <a:off x="2002921" y="2035664"/>
+            <a:ext cx="1131215" cy="1001461"/>
           </a:xfrm>
           <a:custGeom>
             <a:avLst/>
@@ -5473,18 +5473,18 @@
             <a:cxnLst/>
             <a:rect l="l" t="t" r="r" b="b"/>
             <a:pathLst>
-              <a:path w="980386" h="914377">
+              <a:path w="1131215" h="1001461">
                 <a:moveTo>
-                  <a:pt x="980386" y="348334"/>
+                  <a:pt x="1131215" y="348334"/>
                 </a:moveTo>
                 <a:lnTo>
-                  <a:pt x="980386" y="0"/>
-                </a:lnTo>
-                <a:lnTo>
-                  <a:pt x="0" y="566043"/>
-                </a:lnTo>
-                <a:lnTo>
-                  <a:pt x="0" y="914377"/>
+                  <a:pt x="1131215" y="0"/>
+                </a:lnTo>
+                <a:lnTo>
+                  <a:pt x="0" y="653127"/>
+                </a:lnTo>
+                <a:lnTo>
+                  <a:pt x="0" y="1001461"/>
                 </a:lnTo>
                 <a:close/>
               </a:path>
@@ -5530,8 +5530,8 @@
         </p:nvSpPr>
         <p:spPr>
           <a:xfrm>
-            <a:off x="1022535" y="1948581"/>
-            <a:ext cx="1282044" cy="1088544"/>
+            <a:off x="871706" y="2035664"/>
+            <a:ext cx="1131215" cy="1001461"/>
           </a:xfrm>
           <a:custGeom>
             <a:avLst/>
@@ -5540,12 +5540,12 @@
             <a:cxnLst/>
             <a:rect l="l" t="t" r="r" b="b"/>
             <a:pathLst>
-              <a:path w="1282044" h="1088544">
+              <a:path w="1131215" h="1001461">
                 <a:moveTo>
-                  <a:pt x="1282044" y="1088544"/>
+                  <a:pt x="1131215" y="1001461"/>
                 </a:moveTo>
                 <a:lnTo>
-                  <a:pt x="1282044" y="740210"/>
+                  <a:pt x="1131215" y="653127"/>
                 </a:lnTo>
                 <a:lnTo>
                   <a:pt x="0" y="0"/>
@@ -5597,8 +5597,8 @@
         </p:nvCxnSpPr>
         <p:spPr>
           <a:xfrm>
-            <a:off x="3337215" y="2296915"/>
-            <a:ext cx="337710" cy="0"/>
+            <a:off x="3186387" y="2209831"/>
+            <a:ext cx="488538" cy="0"/>
           </a:xfrm>
           <a:prstGeom prst="line">
             <a:avLst/>
@@ -5633,7 +5633,7 @@
         </p:nvSpPr>
         <p:spPr>
           <a:xfrm>
-            <a:off x="3744592" y="2132762"/>
+            <a:off x="3744592" y="2045679"/>
             <a:ext cx="2960840" cy="328305"/>
           </a:xfrm>
           <a:prstGeom prst="rect">
@@ -5668,7 +5668,7 @@
         </p:nvSpPr>
         <p:spPr>
           <a:xfrm>
-            <a:off x="1022535" y="1086454"/>
+            <a:off x="871706" y="1086454"/>
             <a:ext cx="2262430" cy="1306253"/>
           </a:xfrm>
           <a:custGeom>
@@ -5680,16 +5680,16 @@
             <a:pathLst>
               <a:path w="2262430" h="1306253">
                 <a:moveTo>
-                  <a:pt x="980386" y="0"/>
+                  <a:pt x="1131215" y="0"/>
                 </a:moveTo>
                 <a:lnTo>
-                  <a:pt x="2262430" y="740210"/>
-                </a:lnTo>
-                <a:lnTo>
-                  <a:pt x="1282044" y="1306253"/>
-                </a:lnTo>
-                <a:lnTo>
-                  <a:pt x="0" y="566043"/>
+                  <a:pt x="2262430" y="653126"/>
+                </a:lnTo>
+                <a:lnTo>
+                  <a:pt x="1131215" y="1306253"/>
+                </a:lnTo>
+                <a:lnTo>
+                  <a:pt x="0" y="653126"/>
                 </a:lnTo>
                 <a:close/>
               </a:path>
@@ -5735,8 +5735,8 @@
         </p:nvSpPr>
         <p:spPr>
           <a:xfrm>
-            <a:off x="2304579" y="1826664"/>
-            <a:ext cx="980386" cy="862127"/>
+            <a:off x="2002921" y="1739580"/>
+            <a:ext cx="1131215" cy="949211"/>
           </a:xfrm>
           <a:custGeom>
             <a:avLst/>
@@ -5745,18 +5745,18 @@
             <a:cxnLst/>
             <a:rect l="l" t="t" r="r" b="b"/>
             <a:pathLst>
-              <a:path w="980386" h="862127">
+              <a:path w="1131215" h="949211">
                 <a:moveTo>
-                  <a:pt x="980386" y="296084"/>
+                  <a:pt x="1131215" y="296084"/>
                 </a:moveTo>
                 <a:lnTo>
-                  <a:pt x="980386" y="0"/>
-                </a:lnTo>
-                <a:lnTo>
-                  <a:pt x="0" y="566043"/>
-                </a:lnTo>
-                <a:lnTo>
-                  <a:pt x="0" y="862127"/>
+                  <a:pt x="1131215" y="0"/>
+                </a:lnTo>
+                <a:lnTo>
+                  <a:pt x="0" y="653127"/>
+                </a:lnTo>
+                <a:lnTo>
+                  <a:pt x="0" y="949211"/>
                 </a:lnTo>
                 <a:close/>
               </a:path>
@@ -5802,8 +5802,8 @@
         </p:nvSpPr>
         <p:spPr>
           <a:xfrm>
-            <a:off x="1022535" y="1652497"/>
-            <a:ext cx="1282044" cy="1036294"/>
+            <a:off x="871706" y="1739580"/>
+            <a:ext cx="1131215" cy="949211"/>
           </a:xfrm>
           <a:custGeom>
             <a:avLst/>
@@ -5812,12 +5812,12 @@
             <a:cxnLst/>
             <a:rect l="l" t="t" r="r" b="b"/>
             <a:pathLst>
-              <a:path w="1282044" h="1036294">
+              <a:path w="1131215" h="949211">
                 <a:moveTo>
-                  <a:pt x="1282044" y="1036294"/>
+                  <a:pt x="1131215" y="949211"/>
                 </a:moveTo>
                 <a:lnTo>
-                  <a:pt x="1282044" y="740210"/>
+                  <a:pt x="1131215" y="653127"/>
                 </a:lnTo>
                 <a:lnTo>
                   <a:pt x="0" y="0"/>
@@ -5869,8 +5869,8 @@
         </p:nvCxnSpPr>
         <p:spPr>
           <a:xfrm>
-            <a:off x="3337215" y="1974706"/>
-            <a:ext cx="337710" cy="0"/>
+            <a:off x="3186387" y="1887622"/>
+            <a:ext cx="488538" cy="0"/>
           </a:xfrm>
           <a:prstGeom prst="line">
             <a:avLst/>
@@ -5905,7 +5905,7 @@
         </p:nvSpPr>
         <p:spPr>
           <a:xfrm>
-            <a:off x="3744592" y="1810553"/>
+            <a:off x="3744592" y="1723470"/>
             <a:ext cx="2960840" cy="328305"/>
           </a:xfrm>
           <a:prstGeom prst="rect">
@@ -5940,7 +5940,7 @@
         </p:nvSpPr>
         <p:spPr>
           <a:xfrm>
-            <a:off x="-110422" y="314023"/>
+            <a:off x="-261251" y="314023"/>
             <a:ext cx="4528344" cy="430193"/>
           </a:xfrm>
           <a:prstGeom prst="rect">
@@ -5975,8 +5975,8 @@
         </p:nvSpPr>
         <p:spPr>
           <a:xfrm>
-            <a:off x="7790841" y="4665587"/>
-            <a:ext cx="980387" cy="1015911"/>
+            <a:off x="7489184" y="4578503"/>
+            <a:ext cx="1131215" cy="1103469"/>
           </a:xfrm>
           <a:custGeom>
             <a:avLst/>
@@ -5985,222 +5985,252 @@
             <a:cxnLst/>
             <a:rect l="l" t="t" r="r" b="b"/>
             <a:pathLst>
-              <a:path w="980387" h="1015911">
+              <a:path w="1131215" h="1103469">
                 <a:moveTo>
-                  <a:pt x="980387" y="0"/>
+                  <a:pt x="1131215" y="0"/>
                 </a:moveTo>
                 <a:lnTo>
-                  <a:pt x="0" y="566043"/>
-                </a:lnTo>
-                <a:lnTo>
-                  <a:pt x="0" y="966627"/>
-                </a:lnTo>
-                <a:lnTo>
-                  <a:pt x="15562" y="1008468"/>
-                </a:lnTo>
-                <a:lnTo>
-                  <a:pt x="31124" y="1015894"/>
-                </a:lnTo>
-                <a:lnTo>
-                  <a:pt x="46686" y="1015911"/>
-                </a:lnTo>
-                <a:lnTo>
-                  <a:pt x="62247" y="1011050"/>
-                </a:lnTo>
-                <a:lnTo>
-                  <a:pt x="77809" y="1002066"/>
-                </a:lnTo>
-                <a:lnTo>
-                  <a:pt x="93371" y="988957"/>
-                </a:lnTo>
-                <a:lnTo>
-                  <a:pt x="108932" y="970970"/>
-                </a:lnTo>
-                <a:lnTo>
-                  <a:pt x="124494" y="945574"/>
-                </a:lnTo>
-                <a:lnTo>
-                  <a:pt x="140056" y="885764"/>
-                </a:lnTo>
-                <a:lnTo>
-                  <a:pt x="140056" y="885764"/>
-                </a:lnTo>
-                <a:lnTo>
-                  <a:pt x="155617" y="927605"/>
-                </a:lnTo>
-                <a:lnTo>
-                  <a:pt x="171179" y="935030"/>
-                </a:lnTo>
-                <a:lnTo>
-                  <a:pt x="186741" y="935048"/>
-                </a:lnTo>
-                <a:lnTo>
-                  <a:pt x="202302" y="930187"/>
-                </a:lnTo>
-                <a:lnTo>
-                  <a:pt x="217864" y="921202"/>
-                </a:lnTo>
-                <a:lnTo>
-                  <a:pt x="233426" y="908094"/>
-                </a:lnTo>
-                <a:lnTo>
-                  <a:pt x="248987" y="890106"/>
-                </a:lnTo>
-                <a:lnTo>
-                  <a:pt x="264549" y="864711"/>
-                </a:lnTo>
-                <a:lnTo>
-                  <a:pt x="280111" y="804901"/>
-                </a:lnTo>
-                <a:lnTo>
-                  <a:pt x="280111" y="804901"/>
-                </a:lnTo>
-                <a:lnTo>
-                  <a:pt x="295673" y="846741"/>
-                </a:lnTo>
-                <a:lnTo>
-                  <a:pt x="311234" y="854167"/>
-                </a:lnTo>
-                <a:lnTo>
-                  <a:pt x="326796" y="854185"/>
-                </a:lnTo>
-                <a:lnTo>
-                  <a:pt x="342358" y="849324"/>
-                </a:lnTo>
-                <a:lnTo>
-                  <a:pt x="357919" y="840339"/>
-                </a:lnTo>
-                <a:lnTo>
-                  <a:pt x="373481" y="827230"/>
-                </a:lnTo>
-                <a:lnTo>
-                  <a:pt x="389043" y="809243"/>
-                </a:lnTo>
-                <a:lnTo>
-                  <a:pt x="404604" y="783848"/>
-                </a:lnTo>
-                <a:lnTo>
-                  <a:pt x="420166" y="724037"/>
-                </a:lnTo>
-                <a:lnTo>
-                  <a:pt x="420166" y="724037"/>
-                </a:lnTo>
-                <a:lnTo>
-                  <a:pt x="435728" y="765878"/>
-                </a:lnTo>
-                <a:lnTo>
-                  <a:pt x="451289" y="773304"/>
-                </a:lnTo>
-                <a:lnTo>
-                  <a:pt x="466851" y="773321"/>
-                </a:lnTo>
-                <a:lnTo>
-                  <a:pt x="482413" y="768461"/>
-                </a:lnTo>
-                <a:lnTo>
-                  <a:pt x="497975" y="759476"/>
-                </a:lnTo>
-                <a:lnTo>
-                  <a:pt x="513536" y="746367"/>
-                </a:lnTo>
-                <a:lnTo>
-                  <a:pt x="529098" y="728380"/>
-                </a:lnTo>
-                <a:lnTo>
-                  <a:pt x="544660" y="702985"/>
-                </a:lnTo>
-                <a:lnTo>
-                  <a:pt x="560221" y="643174"/>
-                </a:lnTo>
-                <a:lnTo>
-                  <a:pt x="560221" y="643174"/>
-                </a:lnTo>
-                <a:lnTo>
-                  <a:pt x="575783" y="685015"/>
-                </a:lnTo>
-                <a:lnTo>
-                  <a:pt x="591345" y="692441"/>
-                </a:lnTo>
-                <a:lnTo>
-                  <a:pt x="606906" y="692458"/>
-                </a:lnTo>
-                <a:lnTo>
-                  <a:pt x="622468" y="687597"/>
-                </a:lnTo>
-                <a:lnTo>
-                  <a:pt x="638030" y="678613"/>
-                </a:lnTo>
-                <a:lnTo>
-                  <a:pt x="653591" y="665504"/>
-                </a:lnTo>
-                <a:lnTo>
-                  <a:pt x="669153" y="647516"/>
-                </a:lnTo>
-                <a:lnTo>
-                  <a:pt x="684715" y="622121"/>
-                </a:lnTo>
-                <a:lnTo>
-                  <a:pt x="700276" y="562311"/>
-                </a:lnTo>
-                <a:lnTo>
-                  <a:pt x="700276" y="562311"/>
-                </a:lnTo>
-                <a:lnTo>
-                  <a:pt x="715838" y="604152"/>
-                </a:lnTo>
-                <a:lnTo>
-                  <a:pt x="731400" y="611577"/>
-                </a:lnTo>
-                <a:lnTo>
-                  <a:pt x="746962" y="611595"/>
-                </a:lnTo>
-                <a:lnTo>
-                  <a:pt x="762523" y="606734"/>
-                </a:lnTo>
-                <a:lnTo>
-                  <a:pt x="778085" y="597749"/>
-                </a:lnTo>
-                <a:lnTo>
-                  <a:pt x="793647" y="584640"/>
-                </a:lnTo>
-                <a:lnTo>
-                  <a:pt x="809208" y="566653"/>
-                </a:lnTo>
-                <a:lnTo>
-                  <a:pt x="824770" y="541258"/>
-                </a:lnTo>
-                <a:lnTo>
-                  <a:pt x="840332" y="481447"/>
-                </a:lnTo>
-                <a:lnTo>
-                  <a:pt x="840332" y="481447"/>
-                </a:lnTo>
-                <a:lnTo>
-                  <a:pt x="855893" y="523288"/>
-                </a:lnTo>
-                <a:lnTo>
-                  <a:pt x="871455" y="530714"/>
-                </a:lnTo>
-                <a:lnTo>
-                  <a:pt x="887017" y="530732"/>
-                </a:lnTo>
-                <a:lnTo>
-                  <a:pt x="902578" y="525871"/>
-                </a:lnTo>
-                <a:lnTo>
-                  <a:pt x="918140" y="516886"/>
-                </a:lnTo>
-                <a:lnTo>
-                  <a:pt x="933702" y="503777"/>
-                </a:lnTo>
-                <a:lnTo>
-                  <a:pt x="949264" y="485790"/>
-                </a:lnTo>
-                <a:lnTo>
-                  <a:pt x="964825" y="460395"/>
-                </a:lnTo>
-                <a:lnTo>
-                  <a:pt x="980387" y="400584"/>
+                  <a:pt x="0" y="653127"/>
+                </a:lnTo>
+                <a:lnTo>
+                  <a:pt x="0" y="1053711"/>
+                </a:lnTo>
+                <a:lnTo>
+                  <a:pt x="15711" y="1095954"/>
+                </a:lnTo>
+                <a:lnTo>
+                  <a:pt x="31423" y="1103451"/>
+                </a:lnTo>
+                <a:lnTo>
+                  <a:pt x="47134" y="1103469"/>
+                </a:lnTo>
+                <a:lnTo>
+                  <a:pt x="62845" y="1098562"/>
+                </a:lnTo>
+                <a:lnTo>
+                  <a:pt x="78557" y="1089490"/>
+                </a:lnTo>
+                <a:lnTo>
+                  <a:pt x="94268" y="1076256"/>
+                </a:lnTo>
+                <a:lnTo>
+                  <a:pt x="109979" y="1058095"/>
+                </a:lnTo>
+                <a:lnTo>
+                  <a:pt x="125691" y="1032456"/>
+                </a:lnTo>
+                <a:lnTo>
+                  <a:pt x="141402" y="972070"/>
+                </a:lnTo>
+                <a:lnTo>
+                  <a:pt x="141402" y="972070"/>
+                </a:lnTo>
+                <a:lnTo>
+                  <a:pt x="157113" y="1014314"/>
+                </a:lnTo>
+                <a:lnTo>
+                  <a:pt x="172825" y="1021811"/>
+                </a:lnTo>
+                <a:lnTo>
+                  <a:pt x="188536" y="1021828"/>
+                </a:lnTo>
+                <a:lnTo>
+                  <a:pt x="204247" y="1016921"/>
+                </a:lnTo>
+                <a:lnTo>
+                  <a:pt x="219959" y="1007850"/>
+                </a:lnTo>
+                <a:lnTo>
+                  <a:pt x="235670" y="994615"/>
+                </a:lnTo>
+                <a:lnTo>
+                  <a:pt x="251381" y="976455"/>
+                </a:lnTo>
+                <a:lnTo>
+                  <a:pt x="267093" y="950815"/>
+                </a:lnTo>
+                <a:lnTo>
+                  <a:pt x="282804" y="890429"/>
+                </a:lnTo>
+                <a:lnTo>
+                  <a:pt x="282804" y="890429"/>
+                </a:lnTo>
+                <a:lnTo>
+                  <a:pt x="298515" y="932673"/>
+                </a:lnTo>
+                <a:lnTo>
+                  <a:pt x="314226" y="940170"/>
+                </a:lnTo>
+                <a:lnTo>
+                  <a:pt x="329938" y="940188"/>
+                </a:lnTo>
+                <a:lnTo>
+                  <a:pt x="345649" y="935280"/>
+                </a:lnTo>
+                <a:lnTo>
+                  <a:pt x="361360" y="926209"/>
+                </a:lnTo>
+                <a:lnTo>
+                  <a:pt x="377072" y="912974"/>
+                </a:lnTo>
+                <a:lnTo>
+                  <a:pt x="392783" y="894814"/>
+                </a:lnTo>
+                <a:lnTo>
+                  <a:pt x="408494" y="869174"/>
+                </a:lnTo>
+                <a:lnTo>
+                  <a:pt x="424206" y="808789"/>
+                </a:lnTo>
+                <a:lnTo>
+                  <a:pt x="424206" y="808789"/>
+                </a:lnTo>
+                <a:lnTo>
+                  <a:pt x="439917" y="851032"/>
+                </a:lnTo>
+                <a:lnTo>
+                  <a:pt x="455628" y="858529"/>
+                </a:lnTo>
+                <a:lnTo>
+                  <a:pt x="471340" y="858547"/>
+                </a:lnTo>
+                <a:lnTo>
+                  <a:pt x="487051" y="853639"/>
+                </a:lnTo>
+                <a:lnTo>
+                  <a:pt x="502762" y="844568"/>
+                </a:lnTo>
+                <a:lnTo>
+                  <a:pt x="518474" y="831333"/>
+                </a:lnTo>
+                <a:lnTo>
+                  <a:pt x="534185" y="813173"/>
+                </a:lnTo>
+                <a:lnTo>
+                  <a:pt x="549896" y="787534"/>
+                </a:lnTo>
+                <a:lnTo>
+                  <a:pt x="565608" y="727148"/>
+                </a:lnTo>
+                <a:lnTo>
+                  <a:pt x="565608" y="727148"/>
+                </a:lnTo>
+                <a:lnTo>
+                  <a:pt x="581319" y="769391"/>
+                </a:lnTo>
+                <a:lnTo>
+                  <a:pt x="597030" y="776888"/>
+                </a:lnTo>
+                <a:lnTo>
+                  <a:pt x="612742" y="776906"/>
+                </a:lnTo>
+                <a:lnTo>
+                  <a:pt x="628453" y="771998"/>
+                </a:lnTo>
+                <a:lnTo>
+                  <a:pt x="644164" y="762927"/>
+                </a:lnTo>
+                <a:lnTo>
+                  <a:pt x="659876" y="749692"/>
+                </a:lnTo>
+                <a:lnTo>
+                  <a:pt x="675587" y="731532"/>
+                </a:lnTo>
+                <a:lnTo>
+                  <a:pt x="691298" y="705893"/>
+                </a:lnTo>
+                <a:lnTo>
+                  <a:pt x="707010" y="645507"/>
+                </a:lnTo>
+                <a:lnTo>
+                  <a:pt x="707010" y="645507"/>
+                </a:lnTo>
+                <a:lnTo>
+                  <a:pt x="722721" y="687750"/>
+                </a:lnTo>
+                <a:lnTo>
+                  <a:pt x="738432" y="695247"/>
+                </a:lnTo>
+                <a:lnTo>
+                  <a:pt x="754143" y="695265"/>
+                </a:lnTo>
+                <a:lnTo>
+                  <a:pt x="769855" y="690358"/>
+                </a:lnTo>
+                <a:lnTo>
+                  <a:pt x="785566" y="681286"/>
+                </a:lnTo>
+                <a:lnTo>
+                  <a:pt x="801277" y="668052"/>
+                </a:lnTo>
+                <a:lnTo>
+                  <a:pt x="816989" y="649891"/>
+                </a:lnTo>
+                <a:lnTo>
+                  <a:pt x="832700" y="624252"/>
+                </a:lnTo>
+                <a:lnTo>
+                  <a:pt x="848411" y="563866"/>
+                </a:lnTo>
+                <a:lnTo>
+                  <a:pt x="848411" y="563866"/>
+                </a:lnTo>
+                <a:lnTo>
+                  <a:pt x="864123" y="606109"/>
+                </a:lnTo>
+                <a:lnTo>
+                  <a:pt x="879834" y="613606"/>
+                </a:lnTo>
+                <a:lnTo>
+                  <a:pt x="895545" y="613624"/>
+                </a:lnTo>
+                <a:lnTo>
+                  <a:pt x="911257" y="608717"/>
+                </a:lnTo>
+                <a:lnTo>
+                  <a:pt x="926968" y="599646"/>
+                </a:lnTo>
+                <a:lnTo>
+                  <a:pt x="942679" y="586411"/>
+                </a:lnTo>
+                <a:lnTo>
+                  <a:pt x="958391" y="568250"/>
+                </a:lnTo>
+                <a:lnTo>
+                  <a:pt x="974102" y="542611"/>
+                </a:lnTo>
+                <a:lnTo>
+                  <a:pt x="989813" y="482225"/>
+                </a:lnTo>
+                <a:lnTo>
+                  <a:pt x="989813" y="482225"/>
+                </a:lnTo>
+                <a:lnTo>
+                  <a:pt x="1005525" y="524469"/>
+                </a:lnTo>
+                <a:lnTo>
+                  <a:pt x="1021236" y="531966"/>
+                </a:lnTo>
+                <a:lnTo>
+                  <a:pt x="1036947" y="531984"/>
+                </a:lnTo>
+                <a:lnTo>
+                  <a:pt x="1052659" y="527076"/>
+                </a:lnTo>
+                <a:lnTo>
+                  <a:pt x="1068370" y="518005"/>
+                </a:lnTo>
+                <a:lnTo>
+                  <a:pt x="1084081" y="504770"/>
+                </a:lnTo>
+                <a:lnTo>
+                  <a:pt x="1099793" y="486610"/>
+                </a:lnTo>
+                <a:lnTo>
+                  <a:pt x="1115504" y="460970"/>
+                </a:lnTo>
+                <a:lnTo>
+                  <a:pt x="1131215" y="400585"/>
                 </a:lnTo>
                 <a:close/>
               </a:path>
@@ -6246,8 +6276,8 @@
         </p:nvSpPr>
         <p:spPr>
           <a:xfrm>
-            <a:off x="6508798" y="4491420"/>
-            <a:ext cx="1282043" cy="1190921"/>
+            <a:off x="6357969" y="4578503"/>
+            <a:ext cx="1131215" cy="1103469"/>
           </a:xfrm>
           <a:custGeom>
             <a:avLst/>
@@ -6256,282 +6286,252 @@
             <a:cxnLst/>
             <a:rect l="l" t="t" r="r" b="b"/>
             <a:pathLst>
-              <a:path w="1282043" h="1190921">
+              <a:path w="1131215" h="1103469">
                 <a:moveTo>
-                  <a:pt x="1282043" y="740210"/>
+                  <a:pt x="1131215" y="653127"/>
                 </a:moveTo>
                 <a:lnTo>
                   <a:pt x="0" y="0"/>
                 </a:lnTo>
                 <a:lnTo>
-                  <a:pt x="0" y="400584"/>
-                </a:lnTo>
-                <a:lnTo>
-                  <a:pt x="15827" y="461417"/>
-                </a:lnTo>
-                <a:lnTo>
-                  <a:pt x="31655" y="487246"/>
-                </a:lnTo>
-                <a:lnTo>
-                  <a:pt x="47483" y="505541"/>
-                </a:lnTo>
-                <a:lnTo>
-                  <a:pt x="63310" y="518874"/>
-                </a:lnTo>
-                <a:lnTo>
-                  <a:pt x="79138" y="528012"/>
-                </a:lnTo>
-                <a:lnTo>
-                  <a:pt x="94966" y="532956"/>
-                </a:lnTo>
-                <a:lnTo>
-                  <a:pt x="110794" y="532938"/>
-                </a:lnTo>
-                <a:lnTo>
-                  <a:pt x="126621" y="525386"/>
-                </a:lnTo>
-                <a:lnTo>
-                  <a:pt x="142449" y="482830"/>
-                </a:lnTo>
-                <a:lnTo>
-                  <a:pt x="142449" y="482830"/>
-                </a:lnTo>
-                <a:lnTo>
-                  <a:pt x="158277" y="543663"/>
-                </a:lnTo>
-                <a:lnTo>
-                  <a:pt x="174104" y="569492"/>
-                </a:lnTo>
-                <a:lnTo>
-                  <a:pt x="189932" y="587787"/>
-                </a:lnTo>
-                <a:lnTo>
-                  <a:pt x="205760" y="601120"/>
-                </a:lnTo>
-                <a:lnTo>
-                  <a:pt x="221587" y="610258"/>
-                </a:lnTo>
-                <a:lnTo>
-                  <a:pt x="237415" y="615202"/>
-                </a:lnTo>
-                <a:lnTo>
-                  <a:pt x="253243" y="615184"/>
-                </a:lnTo>
-                <a:lnTo>
-                  <a:pt x="269071" y="607631"/>
-                </a:lnTo>
-                <a:lnTo>
-                  <a:pt x="284898" y="565075"/>
-                </a:lnTo>
-                <a:lnTo>
-                  <a:pt x="284898" y="565075"/>
-                </a:lnTo>
-                <a:lnTo>
-                  <a:pt x="300726" y="625908"/>
-                </a:lnTo>
-                <a:lnTo>
-                  <a:pt x="316554" y="651737"/>
-                </a:lnTo>
-                <a:lnTo>
-                  <a:pt x="332381" y="670032"/>
-                </a:lnTo>
-                <a:lnTo>
-                  <a:pt x="348209" y="683365"/>
-                </a:lnTo>
-                <a:lnTo>
-                  <a:pt x="364037" y="692503"/>
-                </a:lnTo>
-                <a:lnTo>
-                  <a:pt x="379864" y="697447"/>
-                </a:lnTo>
-                <a:lnTo>
-                  <a:pt x="395692" y="697429"/>
-                </a:lnTo>
-                <a:lnTo>
-                  <a:pt x="411520" y="689877"/>
-                </a:lnTo>
-                <a:lnTo>
-                  <a:pt x="427348" y="647321"/>
-                </a:lnTo>
-                <a:lnTo>
-                  <a:pt x="427348" y="647321"/>
-                </a:lnTo>
-                <a:lnTo>
-                  <a:pt x="443175" y="708154"/>
-                </a:lnTo>
-                <a:lnTo>
-                  <a:pt x="459003" y="733983"/>
-                </a:lnTo>
-                <a:lnTo>
-                  <a:pt x="474831" y="752278"/>
-                </a:lnTo>
-                <a:lnTo>
-                  <a:pt x="490658" y="765611"/>
-                </a:lnTo>
-                <a:lnTo>
-                  <a:pt x="506486" y="774749"/>
-                </a:lnTo>
-                <a:lnTo>
-                  <a:pt x="522314" y="779693"/>
-                </a:lnTo>
-                <a:lnTo>
-                  <a:pt x="538141" y="779675"/>
-                </a:lnTo>
-                <a:lnTo>
-                  <a:pt x="553969" y="772122"/>
-                </a:lnTo>
-                <a:lnTo>
-                  <a:pt x="569797" y="729566"/>
-                </a:lnTo>
-                <a:lnTo>
-                  <a:pt x="569797" y="729566"/>
-                </a:lnTo>
-                <a:lnTo>
-                  <a:pt x="585625" y="790399"/>
-                </a:lnTo>
-                <a:lnTo>
-                  <a:pt x="601452" y="816229"/>
-                </a:lnTo>
-                <a:lnTo>
-                  <a:pt x="617280" y="834523"/>
-                </a:lnTo>
-                <a:lnTo>
-                  <a:pt x="633108" y="847856"/>
-                </a:lnTo>
-                <a:lnTo>
-                  <a:pt x="648935" y="856995"/>
-                </a:lnTo>
-                <a:lnTo>
-                  <a:pt x="664763" y="861939"/>
-                </a:lnTo>
-                <a:lnTo>
-                  <a:pt x="680591" y="861921"/>
-                </a:lnTo>
-                <a:lnTo>
-                  <a:pt x="696418" y="854368"/>
-                </a:lnTo>
-                <a:lnTo>
-                  <a:pt x="712246" y="811812"/>
-                </a:lnTo>
-                <a:lnTo>
-                  <a:pt x="712246" y="811812"/>
-                </a:lnTo>
-                <a:lnTo>
-                  <a:pt x="728074" y="872645"/>
-                </a:lnTo>
-                <a:lnTo>
-                  <a:pt x="743902" y="898474"/>
-                </a:lnTo>
-                <a:lnTo>
-                  <a:pt x="759729" y="916769"/>
-                </a:lnTo>
-                <a:lnTo>
-                  <a:pt x="775557" y="930102"/>
-                </a:lnTo>
-                <a:lnTo>
-                  <a:pt x="791385" y="939240"/>
-                </a:lnTo>
-                <a:lnTo>
-                  <a:pt x="807212" y="944184"/>
-                </a:lnTo>
-                <a:lnTo>
-                  <a:pt x="823040" y="944166"/>
-                </a:lnTo>
-                <a:lnTo>
-                  <a:pt x="838868" y="936614"/>
-                </a:lnTo>
-                <a:lnTo>
-                  <a:pt x="854696" y="894057"/>
-                </a:lnTo>
-                <a:lnTo>
-                  <a:pt x="854696" y="894057"/>
-                </a:lnTo>
-                <a:lnTo>
-                  <a:pt x="870523" y="954890"/>
-                </a:lnTo>
-                <a:lnTo>
-                  <a:pt x="886351" y="980720"/>
-                </a:lnTo>
-                <a:lnTo>
-                  <a:pt x="902179" y="999014"/>
-                </a:lnTo>
-                <a:lnTo>
-                  <a:pt x="918006" y="1012347"/>
-                </a:lnTo>
-                <a:lnTo>
-                  <a:pt x="933834" y="1021486"/>
-                </a:lnTo>
-                <a:lnTo>
-                  <a:pt x="949662" y="1026430"/>
-                </a:lnTo>
-                <a:lnTo>
-                  <a:pt x="965489" y="1026412"/>
-                </a:lnTo>
-                <a:lnTo>
-                  <a:pt x="981317" y="1018859"/>
-                </a:lnTo>
-                <a:lnTo>
-                  <a:pt x="997145" y="976303"/>
-                </a:lnTo>
-                <a:lnTo>
-                  <a:pt x="997145" y="976303"/>
-                </a:lnTo>
-                <a:lnTo>
-                  <a:pt x="1012973" y="1037136"/>
-                </a:lnTo>
-                <a:lnTo>
-                  <a:pt x="1028800" y="1062965"/>
-                </a:lnTo>
-                <a:lnTo>
-                  <a:pt x="1044628" y="1081260"/>
-                </a:lnTo>
-                <a:lnTo>
-                  <a:pt x="1060456" y="1094593"/>
-                </a:lnTo>
-                <a:lnTo>
-                  <a:pt x="1076283" y="1103731"/>
-                </a:lnTo>
-                <a:lnTo>
-                  <a:pt x="1092111" y="1108675"/>
-                </a:lnTo>
-                <a:lnTo>
-                  <a:pt x="1107939" y="1108657"/>
-                </a:lnTo>
-                <a:lnTo>
-                  <a:pt x="1123766" y="1101105"/>
-                </a:lnTo>
-                <a:lnTo>
-                  <a:pt x="1139594" y="1058549"/>
-                </a:lnTo>
-                <a:lnTo>
-                  <a:pt x="1139594" y="1058549"/>
-                </a:lnTo>
-                <a:lnTo>
-                  <a:pt x="1155422" y="1119382"/>
-                </a:lnTo>
-                <a:lnTo>
-                  <a:pt x="1171250" y="1145211"/>
-                </a:lnTo>
-                <a:lnTo>
-                  <a:pt x="1187077" y="1163506"/>
-                </a:lnTo>
-                <a:lnTo>
-                  <a:pt x="1202905" y="1176838"/>
-                </a:lnTo>
-                <a:lnTo>
-                  <a:pt x="1218733" y="1185977"/>
-                </a:lnTo>
-                <a:lnTo>
-                  <a:pt x="1234560" y="1190921"/>
-                </a:lnTo>
-                <a:lnTo>
-                  <a:pt x="1250388" y="1190903"/>
-                </a:lnTo>
-                <a:lnTo>
-                  <a:pt x="1266216" y="1183350"/>
-                </a:lnTo>
-                <a:lnTo>
-                  <a:pt x="1282043" y="1140794"/>
+                  <a:pt x="0" y="400585"/>
+                </a:lnTo>
+                <a:lnTo>
+                  <a:pt x="15711" y="460970"/>
+                </a:lnTo>
+                <a:lnTo>
+                  <a:pt x="31423" y="486610"/>
+                </a:lnTo>
+                <a:lnTo>
+                  <a:pt x="47134" y="504770"/>
+                </a:lnTo>
+                <a:lnTo>
+                  <a:pt x="62845" y="518005"/>
+                </a:lnTo>
+                <a:lnTo>
+                  <a:pt x="78557" y="527076"/>
+                </a:lnTo>
+                <a:lnTo>
+                  <a:pt x="94268" y="531984"/>
+                </a:lnTo>
+                <a:lnTo>
+                  <a:pt x="109979" y="531966"/>
+                </a:lnTo>
+                <a:lnTo>
+                  <a:pt x="125691" y="524469"/>
+                </a:lnTo>
+                <a:lnTo>
+                  <a:pt x="141402" y="482225"/>
+                </a:lnTo>
+                <a:lnTo>
+                  <a:pt x="141402" y="482225"/>
+                </a:lnTo>
+                <a:lnTo>
+                  <a:pt x="157113" y="542611"/>
+                </a:lnTo>
+                <a:lnTo>
+                  <a:pt x="172824" y="568250"/>
+                </a:lnTo>
+                <a:lnTo>
+                  <a:pt x="188536" y="586411"/>
+                </a:lnTo>
+                <a:lnTo>
+                  <a:pt x="204247" y="599646"/>
+                </a:lnTo>
+                <a:lnTo>
+                  <a:pt x="219958" y="608717"/>
+                </a:lnTo>
+                <a:lnTo>
+                  <a:pt x="235670" y="613624"/>
+                </a:lnTo>
+                <a:lnTo>
+                  <a:pt x="251381" y="613606"/>
+                </a:lnTo>
+                <a:lnTo>
+                  <a:pt x="267092" y="606109"/>
+                </a:lnTo>
+                <a:lnTo>
+                  <a:pt x="282804" y="563866"/>
+                </a:lnTo>
+                <a:lnTo>
+                  <a:pt x="282804" y="563866"/>
+                </a:lnTo>
+                <a:lnTo>
+                  <a:pt x="298515" y="624252"/>
+                </a:lnTo>
+                <a:lnTo>
+                  <a:pt x="314226" y="649891"/>
+                </a:lnTo>
+                <a:lnTo>
+                  <a:pt x="329938" y="668052"/>
+                </a:lnTo>
+                <a:lnTo>
+                  <a:pt x="345649" y="681286"/>
+                </a:lnTo>
+                <a:lnTo>
+                  <a:pt x="361360" y="690358"/>
+                </a:lnTo>
+                <a:lnTo>
+                  <a:pt x="377072" y="695265"/>
+                </a:lnTo>
+                <a:lnTo>
+                  <a:pt x="392783" y="695247"/>
+                </a:lnTo>
+                <a:lnTo>
+                  <a:pt x="408494" y="687750"/>
+                </a:lnTo>
+                <a:lnTo>
+                  <a:pt x="424206" y="645507"/>
+                </a:lnTo>
+                <a:lnTo>
+                  <a:pt x="424206" y="645507"/>
+                </a:lnTo>
+                <a:lnTo>
+                  <a:pt x="439917" y="705893"/>
+                </a:lnTo>
+                <a:lnTo>
+                  <a:pt x="455628" y="731532"/>
+                </a:lnTo>
+                <a:lnTo>
+                  <a:pt x="471340" y="749692"/>
+                </a:lnTo>
+                <a:lnTo>
+                  <a:pt x="487051" y="762927"/>
+                </a:lnTo>
+                <a:lnTo>
+                  <a:pt x="502762" y="771998"/>
+                </a:lnTo>
+                <a:lnTo>
+                  <a:pt x="518474" y="776906"/>
+                </a:lnTo>
+                <a:lnTo>
+                  <a:pt x="534185" y="776888"/>
+                </a:lnTo>
+                <a:lnTo>
+                  <a:pt x="549896" y="769391"/>
+                </a:lnTo>
+                <a:lnTo>
+                  <a:pt x="565608" y="727148"/>
+                </a:lnTo>
+                <a:lnTo>
+                  <a:pt x="565608" y="727148"/>
+                </a:lnTo>
+                <a:lnTo>
+                  <a:pt x="581319" y="787534"/>
+                </a:lnTo>
+                <a:lnTo>
+                  <a:pt x="597030" y="813173"/>
+                </a:lnTo>
+                <a:lnTo>
+                  <a:pt x="612741" y="831333"/>
+                </a:lnTo>
+                <a:lnTo>
+                  <a:pt x="628453" y="844568"/>
+                </a:lnTo>
+                <a:lnTo>
+                  <a:pt x="644164" y="853639"/>
+                </a:lnTo>
+                <a:lnTo>
+                  <a:pt x="659875" y="858547"/>
+                </a:lnTo>
+                <a:lnTo>
+                  <a:pt x="675587" y="858529"/>
+                </a:lnTo>
+                <a:lnTo>
+                  <a:pt x="691298" y="851032"/>
+                </a:lnTo>
+                <a:lnTo>
+                  <a:pt x="707009" y="808789"/>
+                </a:lnTo>
+                <a:lnTo>
+                  <a:pt x="707009" y="808789"/>
+                </a:lnTo>
+                <a:lnTo>
+                  <a:pt x="722721" y="869174"/>
+                </a:lnTo>
+                <a:lnTo>
+                  <a:pt x="738432" y="894814"/>
+                </a:lnTo>
+                <a:lnTo>
+                  <a:pt x="754143" y="912974"/>
+                </a:lnTo>
+                <a:lnTo>
+                  <a:pt x="769855" y="926209"/>
+                </a:lnTo>
+                <a:lnTo>
+                  <a:pt x="785566" y="935280"/>
+                </a:lnTo>
+                <a:lnTo>
+                  <a:pt x="801277" y="940188"/>
+                </a:lnTo>
+                <a:lnTo>
+                  <a:pt x="816989" y="940170"/>
+                </a:lnTo>
+                <a:lnTo>
+                  <a:pt x="832700" y="932673"/>
+                </a:lnTo>
+                <a:lnTo>
+                  <a:pt x="848411" y="890429"/>
+                </a:lnTo>
+                <a:lnTo>
+                  <a:pt x="848411" y="890429"/>
+                </a:lnTo>
+                <a:lnTo>
+                  <a:pt x="864123" y="950815"/>
+                </a:lnTo>
+                <a:lnTo>
+                  <a:pt x="879834" y="976455"/>
+                </a:lnTo>
+                <a:lnTo>
+                  <a:pt x="895545" y="994615"/>
+                </a:lnTo>
+                <a:lnTo>
+                  <a:pt x="911257" y="1007850"/>
+                </a:lnTo>
+                <a:lnTo>
+                  <a:pt x="926968" y="1016921"/>
+                </a:lnTo>
+                <a:lnTo>
+                  <a:pt x="942679" y="1021828"/>
+                </a:lnTo>
+                <a:lnTo>
+                  <a:pt x="958391" y="1021811"/>
+                </a:lnTo>
+                <a:lnTo>
+                  <a:pt x="974102" y="1014314"/>
+                </a:lnTo>
+                <a:lnTo>
+                  <a:pt x="989813" y="972070"/>
+                </a:lnTo>
+                <a:lnTo>
+                  <a:pt x="989813" y="972070"/>
+                </a:lnTo>
+                <a:lnTo>
+                  <a:pt x="1005525" y="1032456"/>
+                </a:lnTo>
+                <a:lnTo>
+                  <a:pt x="1021236" y="1058095"/>
+                </a:lnTo>
+                <a:lnTo>
+                  <a:pt x="1036947" y="1076256"/>
+                </a:lnTo>
+                <a:lnTo>
+                  <a:pt x="1052658" y="1089490"/>
+                </a:lnTo>
+                <a:lnTo>
+                  <a:pt x="1068370" y="1098562"/>
+                </a:lnTo>
+                <a:lnTo>
+                  <a:pt x="1084081" y="1103469"/>
+                </a:lnTo>
+                <a:lnTo>
+                  <a:pt x="1099792" y="1103451"/>
+                </a:lnTo>
+                <a:lnTo>
+                  <a:pt x="1115504" y="1095954"/>
+                </a:lnTo>
+                <a:lnTo>
+                  <a:pt x="1131215" y="1053711"/>
                 </a:lnTo>
                 <a:close/>
               </a:path>
@@ -6577,8 +6577,8 @@
         </p:nvCxnSpPr>
         <p:spPr>
           <a:xfrm>
-            <a:off x="8823478" y="4865879"/>
-            <a:ext cx="337710" cy="0"/>
+            <a:off x="8672649" y="4778795"/>
+            <a:ext cx="488539" cy="0"/>
           </a:xfrm>
           <a:prstGeom prst="line">
             <a:avLst/>
@@ -6613,7 +6613,7 @@
         </p:nvSpPr>
         <p:spPr>
           <a:xfrm>
-            <a:off x="9230855" y="4701727"/>
+            <a:off x="9230855" y="4614643"/>
             <a:ext cx="2873757" cy="328305"/>
           </a:xfrm>
           <a:prstGeom prst="rect">
@@ -6648,8 +6648,8 @@
         </p:nvSpPr>
         <p:spPr>
           <a:xfrm>
-            <a:off x="7790841" y="4378211"/>
-            <a:ext cx="980387" cy="853419"/>
+            <a:off x="7489184" y="4291128"/>
+            <a:ext cx="1131215" cy="940502"/>
           </a:xfrm>
           <a:custGeom>
             <a:avLst/>
@@ -6658,18 +6658,18 @@
             <a:cxnLst/>
             <a:rect l="l" t="t" r="r" b="b"/>
             <a:pathLst>
-              <a:path w="980387" h="853419">
+              <a:path w="1131215" h="940502">
                 <a:moveTo>
-                  <a:pt x="980387" y="287376"/>
+                  <a:pt x="1131215" y="287375"/>
                 </a:moveTo>
                 <a:lnTo>
-                  <a:pt x="980387" y="0"/>
-                </a:lnTo>
-                <a:lnTo>
-                  <a:pt x="0" y="566043"/>
-                </a:lnTo>
-                <a:lnTo>
-                  <a:pt x="0" y="853419"/>
+                  <a:pt x="1131215" y="0"/>
+                </a:lnTo>
+                <a:lnTo>
+                  <a:pt x="0" y="653126"/>
+                </a:lnTo>
+                <a:lnTo>
+                  <a:pt x="0" y="940502"/>
                 </a:lnTo>
                 <a:close/>
               </a:path>
@@ -6715,8 +6715,8 @@
         </p:nvSpPr>
         <p:spPr>
           <a:xfrm>
-            <a:off x="6508798" y="4204044"/>
-            <a:ext cx="1282043" cy="1027586"/>
+            <a:off x="6357969" y="4291128"/>
+            <a:ext cx="1131215" cy="940502"/>
           </a:xfrm>
           <a:custGeom>
             <a:avLst/>
@@ -6725,18 +6725,18 @@
             <a:cxnLst/>
             <a:rect l="l" t="t" r="r" b="b"/>
             <a:pathLst>
-              <a:path w="1282043" h="1027586">
+              <a:path w="1131215" h="940502">
                 <a:moveTo>
-                  <a:pt x="1282043" y="1027586"/>
+                  <a:pt x="1131215" y="940502"/>
                 </a:moveTo>
                 <a:lnTo>
-                  <a:pt x="1282043" y="740210"/>
+                  <a:pt x="1131215" y="653126"/>
                 </a:lnTo>
                 <a:lnTo>
                   <a:pt x="0" y="0"/>
                 </a:lnTo>
                 <a:lnTo>
-                  <a:pt x="0" y="287376"/>
+                  <a:pt x="0" y="287375"/>
                 </a:lnTo>
                 <a:close/>
               </a:path>
@@ -6782,8 +6782,8 @@
         </p:nvCxnSpPr>
         <p:spPr>
           <a:xfrm>
-            <a:off x="8823478" y="4521899"/>
-            <a:ext cx="337710" cy="0"/>
+            <a:off x="8672649" y="4434815"/>
+            <a:ext cx="488539" cy="0"/>
           </a:xfrm>
           <a:prstGeom prst="line">
             <a:avLst/>
@@ -6818,7 +6818,7 @@
         </p:nvSpPr>
         <p:spPr>
           <a:xfrm>
-            <a:off x="9230855" y="4357747"/>
+            <a:off x="9230855" y="4270663"/>
             <a:ext cx="2873757" cy="328305"/>
           </a:xfrm>
           <a:prstGeom prst="rect">
@@ -6853,8 +6853,8 @@
         </p:nvSpPr>
         <p:spPr>
           <a:xfrm>
-            <a:off x="7790841" y="4090836"/>
-            <a:ext cx="980387" cy="853418"/>
+            <a:off x="7489184" y="4003752"/>
+            <a:ext cx="1131215" cy="940502"/>
           </a:xfrm>
           <a:custGeom>
             <a:avLst/>
@@ -6863,18 +6863,18 @@
             <a:cxnLst/>
             <a:rect l="l" t="t" r="r" b="b"/>
             <a:pathLst>
-              <a:path w="980387" h="853418">
+              <a:path w="1131215" h="940502">
                 <a:moveTo>
-                  <a:pt x="980387" y="287375"/>
+                  <a:pt x="1131215" y="287376"/>
                 </a:moveTo>
                 <a:lnTo>
-                  <a:pt x="980387" y="0"/>
-                </a:lnTo>
-                <a:lnTo>
-                  <a:pt x="0" y="566043"/>
-                </a:lnTo>
-                <a:lnTo>
-                  <a:pt x="0" y="853418"/>
+                  <a:pt x="1131215" y="0"/>
+                </a:lnTo>
+                <a:lnTo>
+                  <a:pt x="0" y="653127"/>
+                </a:lnTo>
+                <a:lnTo>
+                  <a:pt x="0" y="940502"/>
                 </a:lnTo>
                 <a:close/>
               </a:path>
@@ -6920,8 +6920,8 @@
         </p:nvSpPr>
         <p:spPr>
           <a:xfrm>
-            <a:off x="6508798" y="3916668"/>
-            <a:ext cx="1282043" cy="1027586"/>
+            <a:off x="6357969" y="4003752"/>
+            <a:ext cx="1131215" cy="940502"/>
           </a:xfrm>
           <a:custGeom>
             <a:avLst/>
@@ -6930,12 +6930,12 @@
             <a:cxnLst/>
             <a:rect l="l" t="t" r="r" b="b"/>
             <a:pathLst>
-              <a:path w="1282043" h="1027586">
+              <a:path w="1131215" h="940502">
                 <a:moveTo>
-                  <a:pt x="1282043" y="1027586"/>
+                  <a:pt x="1131215" y="940502"/>
                 </a:moveTo>
                 <a:lnTo>
-                  <a:pt x="1282043" y="740211"/>
+                  <a:pt x="1131215" y="653127"/>
                 </a:lnTo>
                 <a:lnTo>
                   <a:pt x="0" y="0"/>
@@ -6987,8 +6987,8 @@
         </p:nvCxnSpPr>
         <p:spPr>
           <a:xfrm>
-            <a:off x="8823478" y="4234523"/>
-            <a:ext cx="337710" cy="0"/>
+            <a:off x="8672649" y="4147440"/>
+            <a:ext cx="488539" cy="0"/>
           </a:xfrm>
           <a:prstGeom prst="line">
             <a:avLst/>
@@ -7023,7 +7023,7 @@
         </p:nvSpPr>
         <p:spPr>
           <a:xfrm>
-            <a:off x="9230855" y="4070371"/>
+            <a:off x="9230855" y="3983287"/>
             <a:ext cx="2873757" cy="328305"/>
           </a:xfrm>
           <a:prstGeom prst="rect">
@@ -7058,8 +7058,8 @@
         </p:nvSpPr>
         <p:spPr>
           <a:xfrm>
-            <a:off x="7790841" y="3847002"/>
-            <a:ext cx="980387" cy="809877"/>
+            <a:off x="7489184" y="3759918"/>
+            <a:ext cx="1131215" cy="896961"/>
           </a:xfrm>
           <a:custGeom>
             <a:avLst/>
@@ -7068,18 +7068,18 @@
             <a:cxnLst/>
             <a:rect l="l" t="t" r="r" b="b"/>
             <a:pathLst>
-              <a:path w="980387" h="809877">
+              <a:path w="1131215" h="896961">
                 <a:moveTo>
-                  <a:pt x="980387" y="243834"/>
+                  <a:pt x="1131215" y="243834"/>
                 </a:moveTo>
                 <a:lnTo>
-                  <a:pt x="980387" y="0"/>
-                </a:lnTo>
-                <a:lnTo>
-                  <a:pt x="0" y="566043"/>
-                </a:lnTo>
-                <a:lnTo>
-                  <a:pt x="0" y="809877"/>
+                  <a:pt x="1131215" y="0"/>
+                </a:lnTo>
+                <a:lnTo>
+                  <a:pt x="0" y="653127"/>
+                </a:lnTo>
+                <a:lnTo>
+                  <a:pt x="0" y="896961"/>
                 </a:lnTo>
                 <a:close/>
               </a:path>
@@ -7125,8 +7125,8 @@
         </p:nvSpPr>
         <p:spPr>
           <a:xfrm>
-            <a:off x="6508798" y="3672835"/>
-            <a:ext cx="1282043" cy="984044"/>
+            <a:off x="6357969" y="3759918"/>
+            <a:ext cx="1131215" cy="896961"/>
           </a:xfrm>
           <a:custGeom>
             <a:avLst/>
@@ -7135,18 +7135,18 @@
             <a:cxnLst/>
             <a:rect l="l" t="t" r="r" b="b"/>
             <a:pathLst>
-              <a:path w="1282043" h="984044">
+              <a:path w="1131215" h="896961">
                 <a:moveTo>
-                  <a:pt x="1282043" y="984044"/>
+                  <a:pt x="1131215" y="896961"/>
                 </a:moveTo>
                 <a:lnTo>
-                  <a:pt x="1282043" y="740210"/>
+                  <a:pt x="1131215" y="653127"/>
                 </a:lnTo>
                 <a:lnTo>
                   <a:pt x="0" y="0"/>
                 </a:lnTo>
                 <a:lnTo>
-                  <a:pt x="0" y="243833"/>
+                  <a:pt x="0" y="243834"/>
                 </a:lnTo>
                 <a:close/>
               </a:path>
@@ -7192,8 +7192,8 @@
         </p:nvCxnSpPr>
         <p:spPr>
           <a:xfrm>
-            <a:off x="8823478" y="3968919"/>
-            <a:ext cx="337710" cy="0"/>
+            <a:off x="8672649" y="3881835"/>
+            <a:ext cx="488539" cy="0"/>
           </a:xfrm>
           <a:prstGeom prst="line">
             <a:avLst/>
@@ -7228,7 +7228,7 @@
         </p:nvSpPr>
         <p:spPr>
           <a:xfrm>
-            <a:off x="9230855" y="3804766"/>
+            <a:off x="9230855" y="3717683"/>
             <a:ext cx="2873757" cy="328305"/>
           </a:xfrm>
           <a:prstGeom prst="rect">
@@ -7263,8 +7263,8 @@
         </p:nvSpPr>
         <p:spPr>
           <a:xfrm>
-            <a:off x="7790841" y="3533501"/>
-            <a:ext cx="980387" cy="879544"/>
+            <a:off x="7489184" y="3446417"/>
+            <a:ext cx="1131215" cy="966628"/>
           </a:xfrm>
           <a:custGeom>
             <a:avLst/>
@@ -7273,18 +7273,18 @@
             <a:cxnLst/>
             <a:rect l="l" t="t" r="r" b="b"/>
             <a:pathLst>
-              <a:path w="980387" h="879544">
+              <a:path w="1131215" h="966628">
                 <a:moveTo>
-                  <a:pt x="980387" y="313501"/>
+                  <a:pt x="1131215" y="313501"/>
                 </a:moveTo>
                 <a:lnTo>
-                  <a:pt x="980387" y="0"/>
-                </a:lnTo>
-                <a:lnTo>
-                  <a:pt x="0" y="566043"/>
-                </a:lnTo>
-                <a:lnTo>
-                  <a:pt x="0" y="879544"/>
+                  <a:pt x="1131215" y="0"/>
+                </a:lnTo>
+                <a:lnTo>
+                  <a:pt x="0" y="653127"/>
+                </a:lnTo>
+                <a:lnTo>
+                  <a:pt x="0" y="966628"/>
                 </a:lnTo>
                 <a:close/>
               </a:path>
@@ -7330,8 +7330,8 @@
         </p:nvSpPr>
         <p:spPr>
           <a:xfrm>
-            <a:off x="6508798" y="3359334"/>
-            <a:ext cx="1282043" cy="1053711"/>
+            <a:off x="6357969" y="3446417"/>
+            <a:ext cx="1131215" cy="966628"/>
           </a:xfrm>
           <a:custGeom>
             <a:avLst/>
@@ -7340,12 +7340,12 @@
             <a:cxnLst/>
             <a:rect l="l" t="t" r="r" b="b"/>
             <a:pathLst>
-              <a:path w="1282043" h="1053711">
+              <a:path w="1131215" h="966628">
                 <a:moveTo>
-                  <a:pt x="1282043" y="1053711"/>
+                  <a:pt x="1131215" y="966628"/>
                 </a:moveTo>
                 <a:lnTo>
-                  <a:pt x="1282043" y="740210"/>
+                  <a:pt x="1131215" y="653127"/>
                 </a:lnTo>
                 <a:lnTo>
                   <a:pt x="0" y="0"/>
@@ -7397,8 +7397,8 @@
         </p:nvCxnSpPr>
         <p:spPr>
           <a:xfrm>
-            <a:off x="8823478" y="3690251"/>
-            <a:ext cx="337710" cy="0"/>
+            <a:off x="8672649" y="3603168"/>
+            <a:ext cx="488539" cy="0"/>
           </a:xfrm>
           <a:prstGeom prst="line">
             <a:avLst/>
@@ -7433,7 +7433,7 @@
         </p:nvSpPr>
         <p:spPr>
           <a:xfrm>
-            <a:off x="9230855" y="3526099"/>
+            <a:off x="9230855" y="3439015"/>
             <a:ext cx="2873757" cy="328305"/>
           </a:xfrm>
           <a:prstGeom prst="rect">
@@ -7486,8 +7486,8 @@
         </p:nvSpPr>
         <p:spPr>
           <a:xfrm>
-            <a:off x="7790841" y="3246125"/>
-            <a:ext cx="980387" cy="853419"/>
+            <a:off x="7489184" y="3159042"/>
+            <a:ext cx="1131215" cy="940502"/>
           </a:xfrm>
           <a:custGeom>
             <a:avLst/>
@@ -7496,18 +7496,18 @@
             <a:cxnLst/>
             <a:rect l="l" t="t" r="r" b="b"/>
             <a:pathLst>
-              <a:path w="980387" h="853419">
+              <a:path w="1131215" h="940502">
                 <a:moveTo>
-                  <a:pt x="980387" y="287376"/>
+                  <a:pt x="1131215" y="287375"/>
                 </a:moveTo>
                 <a:lnTo>
-                  <a:pt x="980387" y="0"/>
-                </a:lnTo>
-                <a:lnTo>
-                  <a:pt x="0" y="566043"/>
-                </a:lnTo>
-                <a:lnTo>
-                  <a:pt x="0" y="853419"/>
+                  <a:pt x="1131215" y="0"/>
+                </a:lnTo>
+                <a:lnTo>
+                  <a:pt x="0" y="653126"/>
+                </a:lnTo>
+                <a:lnTo>
+                  <a:pt x="0" y="940502"/>
                 </a:lnTo>
                 <a:close/>
               </a:path>
@@ -7553,8 +7553,8 @@
         </p:nvSpPr>
         <p:spPr>
           <a:xfrm>
-            <a:off x="6508798" y="3071958"/>
-            <a:ext cx="1282043" cy="1027586"/>
+            <a:off x="6357969" y="3159042"/>
+            <a:ext cx="1131215" cy="940502"/>
           </a:xfrm>
           <a:custGeom>
             <a:avLst/>
@@ -7563,18 +7563,18 @@
             <a:cxnLst/>
             <a:rect l="l" t="t" r="r" b="b"/>
             <a:pathLst>
-              <a:path w="1282043" h="1027586">
+              <a:path w="1131215" h="940502">
                 <a:moveTo>
-                  <a:pt x="1282043" y="1027586"/>
+                  <a:pt x="1131215" y="940502"/>
                 </a:moveTo>
                 <a:lnTo>
-                  <a:pt x="1282043" y="740210"/>
+                  <a:pt x="1131215" y="653126"/>
                 </a:lnTo>
                 <a:lnTo>
                   <a:pt x="0" y="0"/>
                 </a:lnTo>
                 <a:lnTo>
-                  <a:pt x="0" y="287376"/>
+                  <a:pt x="0" y="287375"/>
                 </a:lnTo>
                 <a:close/>
               </a:path>
@@ -7620,8 +7620,8 @@
         </p:nvCxnSpPr>
         <p:spPr>
           <a:xfrm>
-            <a:off x="8823478" y="3389813"/>
-            <a:ext cx="337710" cy="0"/>
+            <a:off x="8672649" y="3302730"/>
+            <a:ext cx="488539" cy="0"/>
           </a:xfrm>
           <a:prstGeom prst="line">
             <a:avLst/>
@@ -7656,7 +7656,7 @@
         </p:nvSpPr>
         <p:spPr>
           <a:xfrm>
-            <a:off x="9230855" y="3225661"/>
+            <a:off x="9230855" y="3138577"/>
             <a:ext cx="2873757" cy="328305"/>
           </a:xfrm>
           <a:prstGeom prst="rect">
@@ -7691,8 +7691,8 @@
         </p:nvSpPr>
         <p:spPr>
           <a:xfrm>
-            <a:off x="7790841" y="2984875"/>
-            <a:ext cx="980387" cy="827293"/>
+            <a:off x="7489184" y="2897791"/>
+            <a:ext cx="1131215" cy="914377"/>
           </a:xfrm>
           <a:custGeom>
             <a:avLst/>
@@ -7701,18 +7701,18 @@
             <a:cxnLst/>
             <a:rect l="l" t="t" r="r" b="b"/>
             <a:pathLst>
-              <a:path w="980387" h="827293">
+              <a:path w="1131215" h="914377">
                 <a:moveTo>
-                  <a:pt x="980387" y="261250"/>
+                  <a:pt x="1131215" y="261251"/>
                 </a:moveTo>
                 <a:lnTo>
-                  <a:pt x="980387" y="0"/>
-                </a:lnTo>
-                <a:lnTo>
-                  <a:pt x="0" y="566043"/>
-                </a:lnTo>
-                <a:lnTo>
-                  <a:pt x="0" y="827293"/>
+                  <a:pt x="1131215" y="0"/>
+                </a:lnTo>
+                <a:lnTo>
+                  <a:pt x="0" y="653127"/>
+                </a:lnTo>
+                <a:lnTo>
+                  <a:pt x="0" y="914377"/>
                 </a:lnTo>
                 <a:close/>
               </a:path>
@@ -7758,8 +7758,8 @@
         </p:nvSpPr>
         <p:spPr>
           <a:xfrm>
-            <a:off x="6508798" y="2810708"/>
-            <a:ext cx="1282043" cy="1001460"/>
+            <a:off x="6357969" y="2897791"/>
+            <a:ext cx="1131215" cy="914377"/>
           </a:xfrm>
           <a:custGeom>
             <a:avLst/>
@@ -7768,18 +7768,18 @@
             <a:cxnLst/>
             <a:rect l="l" t="t" r="r" b="b"/>
             <a:pathLst>
-              <a:path w="1282043" h="1001460">
+              <a:path w="1131215" h="914377">
                 <a:moveTo>
-                  <a:pt x="1282043" y="1001460"/>
+                  <a:pt x="1131215" y="914377"/>
                 </a:moveTo>
                 <a:lnTo>
-                  <a:pt x="1282043" y="740210"/>
+                  <a:pt x="1131215" y="653127"/>
                 </a:lnTo>
                 <a:lnTo>
                   <a:pt x="0" y="0"/>
                 </a:lnTo>
                 <a:lnTo>
-                  <a:pt x="0" y="261250"/>
+                  <a:pt x="0" y="261251"/>
                 </a:lnTo>
                 <a:close/>
               </a:path>
@@ -7825,8 +7825,8 @@
         </p:nvCxnSpPr>
         <p:spPr>
           <a:xfrm>
-            <a:off x="8823478" y="3115500"/>
-            <a:ext cx="337710" cy="0"/>
+            <a:off x="8672649" y="3028416"/>
+            <a:ext cx="488539" cy="0"/>
           </a:xfrm>
           <a:prstGeom prst="line">
             <a:avLst/>
@@ -7861,7 +7861,7 @@
         </p:nvSpPr>
         <p:spPr>
           <a:xfrm>
-            <a:off x="9230855" y="2951347"/>
+            <a:off x="9230855" y="2864264"/>
             <a:ext cx="2873757" cy="328305"/>
           </a:xfrm>
           <a:prstGeom prst="rect">
@@ -7896,8 +7896,8 @@
         </p:nvSpPr>
         <p:spPr>
           <a:xfrm>
-            <a:off x="7790841" y="2926093"/>
-            <a:ext cx="980387" cy="624825"/>
+            <a:off x="7489184" y="2839010"/>
+            <a:ext cx="1131215" cy="711908"/>
           </a:xfrm>
           <a:custGeom>
             <a:avLst/>
@@ -7906,18 +7906,18 @@
             <a:cxnLst/>
             <a:rect l="l" t="t" r="r" b="b"/>
             <a:pathLst>
-              <a:path w="980387" h="624825">
+              <a:path w="1131215" h="711908">
                 <a:moveTo>
-                  <a:pt x="980387" y="58782"/>
+                  <a:pt x="1131215" y="58781"/>
                 </a:moveTo>
                 <a:lnTo>
-                  <a:pt x="980387" y="0"/>
-                </a:lnTo>
-                <a:lnTo>
-                  <a:pt x="0" y="566043"/>
-                </a:lnTo>
-                <a:lnTo>
-                  <a:pt x="0" y="624825"/>
+                  <a:pt x="1131215" y="0"/>
+                </a:lnTo>
+                <a:lnTo>
+                  <a:pt x="0" y="653126"/>
+                </a:lnTo>
+                <a:lnTo>
+                  <a:pt x="0" y="711908"/>
                 </a:lnTo>
                 <a:close/>
               </a:path>
@@ -7963,8 +7963,8 @@
         </p:nvSpPr>
         <p:spPr>
           <a:xfrm>
-            <a:off x="6508798" y="2751926"/>
-            <a:ext cx="1282043" cy="798992"/>
+            <a:off x="6357969" y="2839010"/>
+            <a:ext cx="1131215" cy="711908"/>
           </a:xfrm>
           <a:custGeom>
             <a:avLst/>
@@ -7973,18 +7973,18 @@
             <a:cxnLst/>
             <a:rect l="l" t="t" r="r" b="b"/>
             <a:pathLst>
-              <a:path w="1282043" h="798992">
+              <a:path w="1131215" h="711908">
                 <a:moveTo>
-                  <a:pt x="1282043" y="798992"/>
+                  <a:pt x="1131215" y="711908"/>
                 </a:moveTo>
                 <a:lnTo>
-                  <a:pt x="1282043" y="740210"/>
+                  <a:pt x="1131215" y="653126"/>
                 </a:lnTo>
                 <a:lnTo>
                   <a:pt x="0" y="0"/>
                 </a:lnTo>
                 <a:lnTo>
-                  <a:pt x="0" y="58782"/>
+                  <a:pt x="0" y="58781"/>
                 </a:lnTo>
                 <a:close/>
               </a:path>
@@ -8030,8 +8030,8 @@
         </p:nvSpPr>
         <p:spPr>
           <a:xfrm>
-            <a:off x="7790841" y="2867312"/>
-            <a:ext cx="980387" cy="624824"/>
+            <a:off x="7489184" y="2780228"/>
+            <a:ext cx="1131215" cy="711908"/>
           </a:xfrm>
           <a:custGeom>
             <a:avLst/>
@@ -8040,18 +8040,18 @@
             <a:cxnLst/>
             <a:rect l="l" t="t" r="r" b="b"/>
             <a:pathLst>
-              <a:path w="980387" h="624824">
+              <a:path w="1131215" h="711908">
                 <a:moveTo>
-                  <a:pt x="980387" y="58781"/>
+                  <a:pt x="1131215" y="58782"/>
                 </a:moveTo>
                 <a:lnTo>
-                  <a:pt x="980387" y="0"/>
-                </a:lnTo>
-                <a:lnTo>
-                  <a:pt x="0" y="566043"/>
-                </a:lnTo>
-                <a:lnTo>
-                  <a:pt x="0" y="624824"/>
+                  <a:pt x="1131215" y="0"/>
+                </a:lnTo>
+                <a:lnTo>
+                  <a:pt x="0" y="653127"/>
+                </a:lnTo>
+                <a:lnTo>
+                  <a:pt x="0" y="711908"/>
                 </a:lnTo>
                 <a:close/>
               </a:path>
@@ -8097,8 +8097,8 @@
         </p:nvSpPr>
         <p:spPr>
           <a:xfrm>
-            <a:off x="6508798" y="2693145"/>
-            <a:ext cx="1282043" cy="798991"/>
+            <a:off x="6357969" y="2780228"/>
+            <a:ext cx="1131215" cy="711908"/>
           </a:xfrm>
           <a:custGeom>
             <a:avLst/>
@@ -8107,18 +8107,18 @@
             <a:cxnLst/>
             <a:rect l="l" t="t" r="r" b="b"/>
             <a:pathLst>
-              <a:path w="1282043" h="798991">
+              <a:path w="1131215" h="711908">
                 <a:moveTo>
-                  <a:pt x="1282043" y="798991"/>
+                  <a:pt x="1131215" y="711908"/>
                 </a:moveTo>
                 <a:lnTo>
-                  <a:pt x="1282043" y="740210"/>
+                  <a:pt x="1131215" y="653127"/>
                 </a:lnTo>
                 <a:lnTo>
                   <a:pt x="0" y="0"/>
                 </a:lnTo>
                 <a:lnTo>
-                  <a:pt x="0" y="58781"/>
+                  <a:pt x="0" y="58782"/>
                 </a:lnTo>
                 <a:close/>
               </a:path>
@@ -8164,8 +8164,8 @@
         </p:nvSpPr>
         <p:spPr>
           <a:xfrm>
-            <a:off x="7790841" y="2808530"/>
-            <a:ext cx="980387" cy="624825"/>
+            <a:off x="7489184" y="2721447"/>
+            <a:ext cx="1131215" cy="711908"/>
           </a:xfrm>
           <a:custGeom>
             <a:avLst/>
@@ -8174,18 +8174,18 @@
             <a:cxnLst/>
             <a:rect l="l" t="t" r="r" b="b"/>
             <a:pathLst>
-              <a:path w="980387" h="624825">
+              <a:path w="1131215" h="711908">
                 <a:moveTo>
-                  <a:pt x="980387" y="58782"/>
+                  <a:pt x="1131215" y="58781"/>
                 </a:moveTo>
                 <a:lnTo>
-                  <a:pt x="980387" y="0"/>
-                </a:lnTo>
-                <a:lnTo>
-                  <a:pt x="0" y="566043"/>
-                </a:lnTo>
-                <a:lnTo>
-                  <a:pt x="0" y="624825"/>
+                  <a:pt x="1131215" y="0"/>
+                </a:lnTo>
+                <a:lnTo>
+                  <a:pt x="0" y="653126"/>
+                </a:lnTo>
+                <a:lnTo>
+                  <a:pt x="0" y="711908"/>
                 </a:lnTo>
                 <a:close/>
               </a:path>
@@ -8231,8 +8231,8 @@
         </p:nvSpPr>
         <p:spPr>
           <a:xfrm>
-            <a:off x="6508798" y="2634363"/>
-            <a:ext cx="1282043" cy="798992"/>
+            <a:off x="6357969" y="2721447"/>
+            <a:ext cx="1131215" cy="711908"/>
           </a:xfrm>
           <a:custGeom>
             <a:avLst/>
@@ -8241,18 +8241,18 @@
             <a:cxnLst/>
             <a:rect l="l" t="t" r="r" b="b"/>
             <a:pathLst>
-              <a:path w="1282043" h="798992">
+              <a:path w="1131215" h="711908">
                 <a:moveTo>
-                  <a:pt x="1282043" y="798992"/>
+                  <a:pt x="1131215" y="711908"/>
                 </a:moveTo>
                 <a:lnTo>
-                  <a:pt x="1282043" y="740210"/>
+                  <a:pt x="1131215" y="653126"/>
                 </a:lnTo>
                 <a:lnTo>
                   <a:pt x="0" y="0"/>
                 </a:lnTo>
                 <a:lnTo>
-                  <a:pt x="0" y="58782"/>
+                  <a:pt x="0" y="58781"/>
                 </a:lnTo>
                 <a:close/>
               </a:path>
@@ -8298,8 +8298,8 @@
         </p:nvSpPr>
         <p:spPr>
           <a:xfrm>
-            <a:off x="7790841" y="2749749"/>
-            <a:ext cx="980387" cy="624824"/>
+            <a:off x="7489184" y="2662666"/>
+            <a:ext cx="1131215" cy="711907"/>
           </a:xfrm>
           <a:custGeom>
             <a:avLst/>
@@ -8308,18 +8308,18 @@
             <a:cxnLst/>
             <a:rect l="l" t="t" r="r" b="b"/>
             <a:pathLst>
-              <a:path w="980387" h="624824">
+              <a:path w="1131215" h="711907">
                 <a:moveTo>
-                  <a:pt x="980387" y="58781"/>
+                  <a:pt x="1131215" y="58781"/>
                 </a:moveTo>
                 <a:lnTo>
-                  <a:pt x="980387" y="0"/>
-                </a:lnTo>
-                <a:lnTo>
-                  <a:pt x="0" y="566043"/>
-                </a:lnTo>
-                <a:lnTo>
-                  <a:pt x="0" y="624824"/>
+                  <a:pt x="1131215" y="0"/>
+                </a:lnTo>
+                <a:lnTo>
+                  <a:pt x="0" y="653126"/>
+                </a:lnTo>
+                <a:lnTo>
+                  <a:pt x="0" y="711907"/>
                 </a:lnTo>
                 <a:close/>
               </a:path>
@@ -8365,8 +8365,8 @@
         </p:nvSpPr>
         <p:spPr>
           <a:xfrm>
-            <a:off x="6508798" y="2575582"/>
-            <a:ext cx="1282043" cy="798991"/>
+            <a:off x="6357969" y="2662666"/>
+            <a:ext cx="1131215" cy="711907"/>
           </a:xfrm>
           <a:custGeom>
             <a:avLst/>
@@ -8375,12 +8375,12 @@
             <a:cxnLst/>
             <a:rect l="l" t="t" r="r" b="b"/>
             <a:pathLst>
-              <a:path w="1282043" h="798991">
+              <a:path w="1131215" h="711907">
                 <a:moveTo>
-                  <a:pt x="1282043" y="798991"/>
+                  <a:pt x="1131215" y="711907"/>
                 </a:moveTo>
                 <a:lnTo>
-                  <a:pt x="1282043" y="740210"/>
+                  <a:pt x="1131215" y="653126"/>
                 </a:lnTo>
                 <a:lnTo>
                   <a:pt x="0" y="0"/>
@@ -8432,8 +8432,8 @@
         </p:nvSpPr>
         <p:spPr>
           <a:xfrm>
-            <a:off x="7790841" y="2690968"/>
-            <a:ext cx="980387" cy="624824"/>
+            <a:off x="7489184" y="2603884"/>
+            <a:ext cx="1131215" cy="711908"/>
           </a:xfrm>
           <a:custGeom>
             <a:avLst/>
@@ -8442,18 +8442,18 @@
             <a:cxnLst/>
             <a:rect l="l" t="t" r="r" b="b"/>
             <a:pathLst>
-              <a:path w="980387" h="624824">
+              <a:path w="1131215" h="711908">
                 <a:moveTo>
-                  <a:pt x="980387" y="58781"/>
+                  <a:pt x="1131215" y="58782"/>
                 </a:moveTo>
                 <a:lnTo>
-                  <a:pt x="980387" y="0"/>
-                </a:lnTo>
-                <a:lnTo>
-                  <a:pt x="0" y="566043"/>
-                </a:lnTo>
-                <a:lnTo>
-                  <a:pt x="0" y="624824"/>
+                  <a:pt x="1131215" y="0"/>
+                </a:lnTo>
+                <a:lnTo>
+                  <a:pt x="0" y="653127"/>
+                </a:lnTo>
+                <a:lnTo>
+                  <a:pt x="0" y="711908"/>
                 </a:lnTo>
                 <a:close/>
               </a:path>
@@ -8499,8 +8499,8 @@
         </p:nvSpPr>
         <p:spPr>
           <a:xfrm>
-            <a:off x="6508798" y="2516801"/>
-            <a:ext cx="1282043" cy="798991"/>
+            <a:off x="6357969" y="2603884"/>
+            <a:ext cx="1131215" cy="711908"/>
           </a:xfrm>
           <a:custGeom>
             <a:avLst/>
@@ -8509,18 +8509,18 @@
             <a:cxnLst/>
             <a:rect l="l" t="t" r="r" b="b"/>
             <a:pathLst>
-              <a:path w="1282043" h="798991">
+              <a:path w="1131215" h="711908">
                 <a:moveTo>
-                  <a:pt x="1282043" y="798991"/>
+                  <a:pt x="1131215" y="711908"/>
                 </a:moveTo>
                 <a:lnTo>
-                  <a:pt x="1282043" y="740210"/>
+                  <a:pt x="1131215" y="653127"/>
                 </a:lnTo>
                 <a:lnTo>
                   <a:pt x="0" y="0"/>
                 </a:lnTo>
                 <a:lnTo>
-                  <a:pt x="0" y="58781"/>
+                  <a:pt x="0" y="58782"/>
                 </a:lnTo>
                 <a:close/>
               </a:path>
@@ -8566,8 +8566,8 @@
         </p:nvSpPr>
         <p:spPr>
           <a:xfrm>
-            <a:off x="7790841" y="2632186"/>
-            <a:ext cx="980387" cy="624825"/>
+            <a:off x="7489184" y="2545103"/>
+            <a:ext cx="1131215" cy="711908"/>
           </a:xfrm>
           <a:custGeom>
             <a:avLst/>
@@ -8576,18 +8576,18 @@
             <a:cxnLst/>
             <a:rect l="l" t="t" r="r" b="b"/>
             <a:pathLst>
-              <a:path w="980387" h="624825">
+              <a:path w="1131215" h="711908">
                 <a:moveTo>
-                  <a:pt x="980387" y="58782"/>
+                  <a:pt x="1131215" y="58781"/>
                 </a:moveTo>
                 <a:lnTo>
-                  <a:pt x="980387" y="0"/>
-                </a:lnTo>
-                <a:lnTo>
-                  <a:pt x="0" y="566043"/>
-                </a:lnTo>
-                <a:lnTo>
-                  <a:pt x="0" y="624825"/>
+                  <a:pt x="1131215" y="0"/>
+                </a:lnTo>
+                <a:lnTo>
+                  <a:pt x="0" y="653126"/>
+                </a:lnTo>
+                <a:lnTo>
+                  <a:pt x="0" y="711908"/>
                 </a:lnTo>
                 <a:close/>
               </a:path>
@@ -8633,8 +8633,8 @@
         </p:nvSpPr>
         <p:spPr>
           <a:xfrm>
-            <a:off x="6508798" y="2458019"/>
-            <a:ext cx="1282043" cy="798992"/>
+            <a:off x="6357969" y="2545103"/>
+            <a:ext cx="1131215" cy="711908"/>
           </a:xfrm>
           <a:custGeom>
             <a:avLst/>
@@ -8643,18 +8643,18 @@
             <a:cxnLst/>
             <a:rect l="l" t="t" r="r" b="b"/>
             <a:pathLst>
-              <a:path w="1282043" h="798992">
+              <a:path w="1131215" h="711908">
                 <a:moveTo>
-                  <a:pt x="1282043" y="798992"/>
+                  <a:pt x="1131215" y="711908"/>
                 </a:moveTo>
                 <a:lnTo>
-                  <a:pt x="1282043" y="740210"/>
+                  <a:pt x="1131215" y="653126"/>
                 </a:lnTo>
                 <a:lnTo>
                   <a:pt x="0" y="0"/>
                 </a:lnTo>
                 <a:lnTo>
-                  <a:pt x="0" y="58782"/>
+                  <a:pt x="0" y="58781"/>
                 </a:lnTo>
                 <a:close/>
               </a:path>
@@ -8700,8 +8700,8 @@
         </p:nvSpPr>
         <p:spPr>
           <a:xfrm>
-            <a:off x="7790841" y="2573405"/>
-            <a:ext cx="980387" cy="624824"/>
+            <a:off x="7489184" y="2486321"/>
+            <a:ext cx="1131215" cy="711908"/>
           </a:xfrm>
           <a:custGeom>
             <a:avLst/>
@@ -8710,18 +8710,18 @@
             <a:cxnLst/>
             <a:rect l="l" t="t" r="r" b="b"/>
             <a:pathLst>
-              <a:path w="980387" h="624824">
+              <a:path w="1131215" h="711908">
                 <a:moveTo>
-                  <a:pt x="980387" y="58781"/>
+                  <a:pt x="1131215" y="58782"/>
                 </a:moveTo>
                 <a:lnTo>
-                  <a:pt x="980387" y="0"/>
-                </a:lnTo>
-                <a:lnTo>
-                  <a:pt x="0" y="566043"/>
-                </a:lnTo>
-                <a:lnTo>
-                  <a:pt x="0" y="624824"/>
+                  <a:pt x="1131215" y="0"/>
+                </a:lnTo>
+                <a:lnTo>
+                  <a:pt x="0" y="653127"/>
+                </a:lnTo>
+                <a:lnTo>
+                  <a:pt x="0" y="711908"/>
                 </a:lnTo>
                 <a:close/>
               </a:path>
@@ -8767,8 +8767,8 @@
         </p:nvSpPr>
         <p:spPr>
           <a:xfrm>
-            <a:off x="6508798" y="2399238"/>
-            <a:ext cx="1282043" cy="798991"/>
+            <a:off x="6357969" y="2486321"/>
+            <a:ext cx="1131215" cy="711908"/>
           </a:xfrm>
           <a:custGeom>
             <a:avLst/>
@@ -8777,18 +8777,18 @@
             <a:cxnLst/>
             <a:rect l="l" t="t" r="r" b="b"/>
             <a:pathLst>
-              <a:path w="1282043" h="798991">
+              <a:path w="1131215" h="711908">
                 <a:moveTo>
-                  <a:pt x="1282043" y="798991"/>
+                  <a:pt x="1131215" y="711908"/>
                 </a:moveTo>
                 <a:lnTo>
-                  <a:pt x="1282043" y="740210"/>
+                  <a:pt x="1131215" y="653127"/>
                 </a:lnTo>
                 <a:lnTo>
                   <a:pt x="0" y="0"/>
                 </a:lnTo>
                 <a:lnTo>
-                  <a:pt x="0" y="58781"/>
+                  <a:pt x="0" y="58782"/>
                 </a:lnTo>
                 <a:close/>
               </a:path>
@@ -8834,7 +8834,7 @@
         </p:nvSpPr>
         <p:spPr>
           <a:xfrm>
-            <a:off x="6508798" y="1774413"/>
+            <a:off x="6357969" y="1774413"/>
             <a:ext cx="2262430" cy="1306254"/>
           </a:xfrm>
           <a:custGeom>
@@ -8846,16 +8846,16 @@
             <a:pathLst>
               <a:path w="2262430" h="1306254">
                 <a:moveTo>
-                  <a:pt x="980386" y="0"/>
+                  <a:pt x="1131215" y="0"/>
                 </a:moveTo>
                 <a:lnTo>
-                  <a:pt x="2262430" y="740211"/>
-                </a:lnTo>
-                <a:lnTo>
-                  <a:pt x="1282043" y="1306254"/>
-                </a:lnTo>
-                <a:lnTo>
-                  <a:pt x="0" y="566043"/>
+                  <a:pt x="2262430" y="653127"/>
+                </a:lnTo>
+                <a:lnTo>
+                  <a:pt x="1131215" y="1306254"/>
+                </a:lnTo>
+                <a:lnTo>
+                  <a:pt x="0" y="653127"/>
                 </a:lnTo>
                 <a:close/>
               </a:path>
@@ -8901,8 +8901,8 @@
         </p:nvSpPr>
         <p:spPr>
           <a:xfrm>
-            <a:off x="7790841" y="2514624"/>
-            <a:ext cx="980387" cy="624824"/>
+            <a:off x="7489184" y="2427540"/>
+            <a:ext cx="1131215" cy="711908"/>
           </a:xfrm>
           <a:custGeom>
             <a:avLst/>
@@ -8911,18 +8911,18 @@
             <a:cxnLst/>
             <a:rect l="l" t="t" r="r" b="b"/>
             <a:pathLst>
-              <a:path w="980387" h="624824">
+              <a:path w="1131215" h="711908">
                 <a:moveTo>
-                  <a:pt x="980387" y="58781"/>
+                  <a:pt x="1131215" y="58781"/>
                 </a:moveTo>
                 <a:lnTo>
-                  <a:pt x="980387" y="0"/>
-                </a:lnTo>
-                <a:lnTo>
-                  <a:pt x="0" y="566043"/>
-                </a:lnTo>
-                <a:lnTo>
-                  <a:pt x="0" y="624824"/>
+                  <a:pt x="1131215" y="0"/>
+                </a:lnTo>
+                <a:lnTo>
+                  <a:pt x="0" y="653127"/>
+                </a:lnTo>
+                <a:lnTo>
+                  <a:pt x="0" y="711908"/>
                 </a:lnTo>
                 <a:close/>
               </a:path>
@@ -8968,8 +8968,8 @@
         </p:nvSpPr>
         <p:spPr>
           <a:xfrm>
-            <a:off x="6508798" y="2340456"/>
-            <a:ext cx="1282043" cy="798992"/>
+            <a:off x="6357969" y="2427540"/>
+            <a:ext cx="1131215" cy="711908"/>
           </a:xfrm>
           <a:custGeom>
             <a:avLst/>
@@ -8978,18 +8978,18 @@
             <a:cxnLst/>
             <a:rect l="l" t="t" r="r" b="b"/>
             <a:pathLst>
-              <a:path w="1282043" h="798992">
+              <a:path w="1131215" h="711908">
                 <a:moveTo>
-                  <a:pt x="1282043" y="798992"/>
+                  <a:pt x="1131215" y="711908"/>
                 </a:moveTo>
                 <a:lnTo>
-                  <a:pt x="1282043" y="740211"/>
+                  <a:pt x="1131215" y="653127"/>
                 </a:lnTo>
                 <a:lnTo>
                   <a:pt x="0" y="0"/>
                 </a:lnTo>
                 <a:lnTo>
-                  <a:pt x="0" y="58782"/>
+                  <a:pt x="0" y="58781"/>
                 </a:lnTo>
                 <a:close/>
               </a:path>
@@ -9035,8 +9035,8 @@
         </p:nvCxnSpPr>
         <p:spPr>
           <a:xfrm>
-            <a:off x="8823478" y="2749749"/>
-            <a:ext cx="337710" cy="0"/>
+            <a:off x="8672649" y="2662666"/>
+            <a:ext cx="488539" cy="0"/>
           </a:xfrm>
           <a:prstGeom prst="line">
             <a:avLst/>
@@ -9071,7 +9071,7 @@
         </p:nvSpPr>
         <p:spPr>
           <a:xfrm>
-            <a:off x="9230855" y="2585597"/>
+            <a:off x="9230855" y="2498513"/>
             <a:ext cx="2873757" cy="328305"/>
           </a:xfrm>
           <a:prstGeom prst="rect">
@@ -9106,7 +9106,7 @@
         </p:nvSpPr>
         <p:spPr>
           <a:xfrm>
-            <a:off x="5375841" y="314023"/>
+            <a:off x="5225012" y="314023"/>
             <a:ext cx="4528344" cy="430193"/>
           </a:xfrm>
           <a:prstGeom prst="rect">
@@ -9141,8 +9141,8 @@
         </p:nvCxnSpPr>
         <p:spPr>
           <a:xfrm flipH="1">
-            <a:off x="1286677" y="5444501"/>
-            <a:ext cx="505084" cy="374459"/>
+            <a:off x="1045351" y="5478729"/>
+            <a:ext cx="505084" cy="374460"/>
           </a:xfrm>
           <a:prstGeom prst="line">
             <a:avLst/>
@@ -9178,7 +9178,7 @@
         </p:nvCxnSpPr>
         <p:spPr>
           <a:xfrm>
-            <a:off x="2304579" y="5740585"/>
+            <a:off x="2002921" y="5739980"/>
             <a:ext cx="0" cy="566043"/>
           </a:xfrm>
           <a:prstGeom prst="line">
@@ -9215,8 +9215,8 @@
         </p:nvCxnSpPr>
         <p:spPr>
           <a:xfrm>
-            <a:off x="2696733" y="5512785"/>
-            <a:ext cx="505085" cy="374459"/>
+            <a:off x="2455407" y="5478729"/>
+            <a:ext cx="505085" cy="374460"/>
           </a:xfrm>
           <a:prstGeom prst="line">
             <a:avLst/>
@@ -9252,7 +9252,7 @@
         </p:nvSpPr>
         <p:spPr>
           <a:xfrm>
-            <a:off x="998326" y="6409822"/>
+            <a:off x="696668" y="6409217"/>
             <a:ext cx="2612506" cy="350947"/>
           </a:xfrm>
           <a:prstGeom prst="rect">
@@ -9287,8 +9287,8 @@
         </p:nvCxnSpPr>
         <p:spPr>
           <a:xfrm flipH="1">
-            <a:off x="6772939" y="5444501"/>
-            <a:ext cx="505085" cy="374459"/>
+            <a:off x="6531614" y="5478729"/>
+            <a:ext cx="505084" cy="374460"/>
           </a:xfrm>
           <a:prstGeom prst="line">
             <a:avLst/>
@@ -9324,7 +9324,7 @@
         </p:nvCxnSpPr>
         <p:spPr>
           <a:xfrm>
-            <a:off x="7790841" y="5740585"/>
+            <a:off x="7489184" y="5739980"/>
             <a:ext cx="0" cy="566043"/>
           </a:xfrm>
           <a:prstGeom prst="line">
@@ -9361,8 +9361,8 @@
         </p:nvCxnSpPr>
         <p:spPr>
           <a:xfrm>
-            <a:off x="8182996" y="5512785"/>
-            <a:ext cx="505085" cy="374459"/>
+            <a:off x="7941670" y="5478729"/>
+            <a:ext cx="505085" cy="374460"/>
           </a:xfrm>
           <a:prstGeom prst="line">
             <a:avLst/>
@@ -9398,7 +9398,7 @@
         </p:nvSpPr>
         <p:spPr>
           <a:xfrm>
-            <a:off x="6484588" y="6409822"/>
+            <a:off x="6182931" y="6409217"/>
             <a:ext cx="2612506" cy="350947"/>
           </a:xfrm>
           <a:prstGeom prst="rect">

</xml_diff>